<commit_message>
fix: convert body array to string with line breaks
</commit_message>
<xml_diff>
--- a/deliverables/bingli-presentation-image/presentation.pptx
+++ b/deliverables/bingli-presentation-image/presentation.pptx
@@ -4,9 +4,20 @@
   <p:sldMasterIdLst>
     <p:sldMasterId id="2147483648" r:id="rId1"/>
   </p:sldMasterIdLst>
-  <p:sldIdLst/>
+  <p:sldIdLst>
+    <p:sldId id="256" r:id="rId2"/>
+    <p:sldId id="257" r:id="rId3"/>
+    <p:sldId id="258" r:id="rId4"/>
+    <p:sldId id="259" r:id="rId5"/>
+    <p:sldId id="260" r:id="rId6"/>
+    <p:sldId id="261" r:id="rId7"/>
+    <p:sldId id="262" r:id="rId8"/>
+    <p:sldId id="263" r:id="rId9"/>
+    <p:sldId id="264" r:id="rId10"/>
+    <p:sldId id="265" r:id="rId11"/>
+  </p:sldIdLst>
   <p:notesMasterIdLst>
-    <p:notesMasterId r:id="rId2"/>
+    <p:notesMasterId r:id="rId12"/>
   </p:notesMasterIdLst>
   <p:sldSz cx="9144000" cy="5143500"/>
   <p:notesSz cx="5143500" cy="9144000"/>
@@ -452,6 +463,886 @@
     </a:lvl9pPr>
   </p:notesStyle>
 </p:notesMaster>
+</file>
+
+<file path=ppt/notesSlides/notesSlide1.xml><?xml version="1.0" encoding="utf-8"?>
+<p:notes xmlns:a="http://schemas.openxmlformats.org/drawingml/2006/main" xmlns:r="http://schemas.openxmlformats.org/officeDocument/2006/relationships" xmlns:p="http://schemas.openxmlformats.org/presentationml/2006/main">
+  <p:cSld>
+    <p:spTree>
+      <p:nvGrpSpPr>
+        <p:cNvPr id="1" name=""/>
+        <p:cNvGrpSpPr/>
+        <p:nvPr/>
+      </p:nvGrpSpPr>
+      <p:grpSpPr>
+        <a:xfrm>
+          <a:off x="0" y="0"/>
+          <a:ext cx="0" cy="0"/>
+          <a:chOff x="0" y="0"/>
+          <a:chExt cx="0" cy="0"/>
+        </a:xfrm>
+      </p:grpSpPr>
+      <p:sp>
+        <p:nvSpPr>
+          <p:cNvPr id="2" name="Slide Image Placeholder 1"/>
+          <p:cNvSpPr>
+            <a:spLocks noGrp="1" noRot="1" noChangeAspect="1"/>
+          </p:cNvSpPr>
+          <p:nvPr>
+            <p:ph type="sldImg"/>
+          </p:nvPr>
+        </p:nvSpPr>
+        <p:spPr/>
+      </p:sp>
+      <p:sp>
+        <p:nvSpPr>
+          <p:cNvPr id="3" name="Notes Placeholder 2"/>
+          <p:cNvSpPr>
+            <a:spLocks noGrp="1"/>
+          </p:cNvSpPr>
+          <p:nvPr>
+            <p:ph type="body" idx="1"/>
+          </p:nvPr>
+        </p:nvSpPr>
+        <p:spPr/>
+        <p:txBody>
+          <a:bodyPr/>
+          <a:lstStyle/>
+          <a:p>
+            <a:r>
+              <a:rPr lang="en-US" dirty="0"/>
+              <a:t/>
+            </a:r>
+            <a:endParaRPr lang="en-US" dirty="0"/>
+          </a:p>
+        </p:txBody>
+      </p:sp>
+      <p:sp>
+        <p:nvSpPr>
+          <p:cNvPr id="4" name="Slide Number Placeholder 3"/>
+          <p:cNvSpPr>
+            <a:spLocks noGrp="1"/>
+          </p:cNvSpPr>
+          <p:nvPr>
+            <p:ph type="sldNum" sz="quarter" idx="10"/>
+          </p:nvPr>
+        </p:nvSpPr>
+        <p:spPr/>
+        <p:txBody>
+          <a:bodyPr/>
+          <a:lstStyle/>
+          <a:p>
+            <a:fld id="{F7021451-1387-4CA6-816F-3879F97B5CBC}" type="slidenum">
+              <a:rPr lang="en-US"/>
+              <a:t>1</a:t>
+            </a:fld>
+            <a:endParaRPr lang="en-US"/>
+          </a:p>
+        </p:txBody>
+      </p:sp>
+    </p:spTree>
+    <p:extLst>
+      <p:ext uri="{BB962C8B-B14F-4D97-AF65-F5344CB8AC3E}">
+        <p14:creationId xmlns:p14="http://schemas.microsoft.com/office/powerpoint/2010/main" val="1024086991"/>
+      </p:ext>
+    </p:extLst>
+  </p:cSld>
+  <p:clrMapOvr>
+    <a:masterClrMapping/>
+  </p:clrMapOvr>
+</p:notes>
+</file>
+
+<file path=ppt/notesSlides/notesSlide10.xml><?xml version="1.0" encoding="utf-8"?>
+<p:notes xmlns:a="http://schemas.openxmlformats.org/drawingml/2006/main" xmlns:r="http://schemas.openxmlformats.org/officeDocument/2006/relationships" xmlns:p="http://schemas.openxmlformats.org/presentationml/2006/main">
+  <p:cSld>
+    <p:spTree>
+      <p:nvGrpSpPr>
+        <p:cNvPr id="1" name=""/>
+        <p:cNvGrpSpPr/>
+        <p:nvPr/>
+      </p:nvGrpSpPr>
+      <p:grpSpPr>
+        <a:xfrm>
+          <a:off x="0" y="0"/>
+          <a:ext cx="0" cy="0"/>
+          <a:chOff x="0" y="0"/>
+          <a:chExt cx="0" cy="0"/>
+        </a:xfrm>
+      </p:grpSpPr>
+      <p:sp>
+        <p:nvSpPr>
+          <p:cNvPr id="2" name="Slide Image Placeholder 1"/>
+          <p:cNvSpPr>
+            <a:spLocks noGrp="1" noRot="1" noChangeAspect="1"/>
+          </p:cNvSpPr>
+          <p:nvPr>
+            <p:ph type="sldImg"/>
+          </p:nvPr>
+        </p:nvSpPr>
+        <p:spPr/>
+      </p:sp>
+      <p:sp>
+        <p:nvSpPr>
+          <p:cNvPr id="3" name="Notes Placeholder 2"/>
+          <p:cNvSpPr>
+            <a:spLocks noGrp="1"/>
+          </p:cNvSpPr>
+          <p:nvPr>
+            <p:ph type="body" idx="1"/>
+          </p:nvPr>
+        </p:nvSpPr>
+        <p:spPr/>
+        <p:txBody>
+          <a:bodyPr/>
+          <a:lstStyle/>
+          <a:p>
+            <a:r>
+              <a:rPr lang="en-US" dirty="0"/>
+              <a:t/>
+            </a:r>
+            <a:endParaRPr lang="en-US" dirty="0"/>
+          </a:p>
+        </p:txBody>
+      </p:sp>
+      <p:sp>
+        <p:nvSpPr>
+          <p:cNvPr id="4" name="Slide Number Placeholder 3"/>
+          <p:cNvSpPr>
+            <a:spLocks noGrp="1"/>
+          </p:cNvSpPr>
+          <p:nvPr>
+            <p:ph type="sldNum" sz="quarter" idx="10"/>
+          </p:nvPr>
+        </p:nvSpPr>
+        <p:spPr/>
+        <p:txBody>
+          <a:bodyPr/>
+          <a:lstStyle/>
+          <a:p>
+            <a:fld id="{F7021451-1387-4CA6-816F-3879F97B5CBC}" type="slidenum">
+              <a:rPr lang="en-US"/>
+              <a:t>10</a:t>
+            </a:fld>
+            <a:endParaRPr lang="en-US"/>
+          </a:p>
+        </p:txBody>
+      </p:sp>
+    </p:spTree>
+    <p:extLst>
+      <p:ext uri="{BB962C8B-B14F-4D97-AF65-F5344CB8AC3E}">
+        <p14:creationId xmlns:p14="http://schemas.microsoft.com/office/powerpoint/2010/main" val="1024086991"/>
+      </p:ext>
+    </p:extLst>
+  </p:cSld>
+  <p:clrMapOvr>
+    <a:masterClrMapping/>
+  </p:clrMapOvr>
+</p:notes>
+</file>
+
+<file path=ppt/notesSlides/notesSlide2.xml><?xml version="1.0" encoding="utf-8"?>
+<p:notes xmlns:a="http://schemas.openxmlformats.org/drawingml/2006/main" xmlns:r="http://schemas.openxmlformats.org/officeDocument/2006/relationships" xmlns:p="http://schemas.openxmlformats.org/presentationml/2006/main">
+  <p:cSld>
+    <p:spTree>
+      <p:nvGrpSpPr>
+        <p:cNvPr id="1" name=""/>
+        <p:cNvGrpSpPr/>
+        <p:nvPr/>
+      </p:nvGrpSpPr>
+      <p:grpSpPr>
+        <a:xfrm>
+          <a:off x="0" y="0"/>
+          <a:ext cx="0" cy="0"/>
+          <a:chOff x="0" y="0"/>
+          <a:chExt cx="0" cy="0"/>
+        </a:xfrm>
+      </p:grpSpPr>
+      <p:sp>
+        <p:nvSpPr>
+          <p:cNvPr id="2" name="Slide Image Placeholder 1"/>
+          <p:cNvSpPr>
+            <a:spLocks noGrp="1" noRot="1" noChangeAspect="1"/>
+          </p:cNvSpPr>
+          <p:nvPr>
+            <p:ph type="sldImg"/>
+          </p:nvPr>
+        </p:nvSpPr>
+        <p:spPr/>
+      </p:sp>
+      <p:sp>
+        <p:nvSpPr>
+          <p:cNvPr id="3" name="Notes Placeholder 2"/>
+          <p:cNvSpPr>
+            <a:spLocks noGrp="1"/>
+          </p:cNvSpPr>
+          <p:nvPr>
+            <p:ph type="body" idx="1"/>
+          </p:nvPr>
+        </p:nvSpPr>
+        <p:spPr/>
+        <p:txBody>
+          <a:bodyPr/>
+          <a:lstStyle/>
+          <a:p>
+            <a:r>
+              <a:rPr lang="en-US" dirty="0"/>
+              <a:t/>
+            </a:r>
+            <a:endParaRPr lang="en-US" dirty="0"/>
+          </a:p>
+        </p:txBody>
+      </p:sp>
+      <p:sp>
+        <p:nvSpPr>
+          <p:cNvPr id="4" name="Slide Number Placeholder 3"/>
+          <p:cNvSpPr>
+            <a:spLocks noGrp="1"/>
+          </p:cNvSpPr>
+          <p:nvPr>
+            <p:ph type="sldNum" sz="quarter" idx="10"/>
+          </p:nvPr>
+        </p:nvSpPr>
+        <p:spPr/>
+        <p:txBody>
+          <a:bodyPr/>
+          <a:lstStyle/>
+          <a:p>
+            <a:fld id="{F7021451-1387-4CA6-816F-3879F97B5CBC}" type="slidenum">
+              <a:rPr lang="en-US"/>
+              <a:t>2</a:t>
+            </a:fld>
+            <a:endParaRPr lang="en-US"/>
+          </a:p>
+        </p:txBody>
+      </p:sp>
+    </p:spTree>
+    <p:extLst>
+      <p:ext uri="{BB962C8B-B14F-4D97-AF65-F5344CB8AC3E}">
+        <p14:creationId xmlns:p14="http://schemas.microsoft.com/office/powerpoint/2010/main" val="1024086991"/>
+      </p:ext>
+    </p:extLst>
+  </p:cSld>
+  <p:clrMapOvr>
+    <a:masterClrMapping/>
+  </p:clrMapOvr>
+</p:notes>
+</file>
+
+<file path=ppt/notesSlides/notesSlide3.xml><?xml version="1.0" encoding="utf-8"?>
+<p:notes xmlns:a="http://schemas.openxmlformats.org/drawingml/2006/main" xmlns:r="http://schemas.openxmlformats.org/officeDocument/2006/relationships" xmlns:p="http://schemas.openxmlformats.org/presentationml/2006/main">
+  <p:cSld>
+    <p:spTree>
+      <p:nvGrpSpPr>
+        <p:cNvPr id="1" name=""/>
+        <p:cNvGrpSpPr/>
+        <p:nvPr/>
+      </p:nvGrpSpPr>
+      <p:grpSpPr>
+        <a:xfrm>
+          <a:off x="0" y="0"/>
+          <a:ext cx="0" cy="0"/>
+          <a:chOff x="0" y="0"/>
+          <a:chExt cx="0" cy="0"/>
+        </a:xfrm>
+      </p:grpSpPr>
+      <p:sp>
+        <p:nvSpPr>
+          <p:cNvPr id="2" name="Slide Image Placeholder 1"/>
+          <p:cNvSpPr>
+            <a:spLocks noGrp="1" noRot="1" noChangeAspect="1"/>
+          </p:cNvSpPr>
+          <p:nvPr>
+            <p:ph type="sldImg"/>
+          </p:nvPr>
+        </p:nvSpPr>
+        <p:spPr/>
+      </p:sp>
+      <p:sp>
+        <p:nvSpPr>
+          <p:cNvPr id="3" name="Notes Placeholder 2"/>
+          <p:cNvSpPr>
+            <a:spLocks noGrp="1"/>
+          </p:cNvSpPr>
+          <p:nvPr>
+            <p:ph type="body" idx="1"/>
+          </p:nvPr>
+        </p:nvSpPr>
+        <p:spPr/>
+        <p:txBody>
+          <a:bodyPr/>
+          <a:lstStyle/>
+          <a:p>
+            <a:r>
+              <a:rPr lang="en-US" dirty="0"/>
+              <a:t/>
+            </a:r>
+            <a:endParaRPr lang="en-US" dirty="0"/>
+          </a:p>
+        </p:txBody>
+      </p:sp>
+      <p:sp>
+        <p:nvSpPr>
+          <p:cNvPr id="4" name="Slide Number Placeholder 3"/>
+          <p:cNvSpPr>
+            <a:spLocks noGrp="1"/>
+          </p:cNvSpPr>
+          <p:nvPr>
+            <p:ph type="sldNum" sz="quarter" idx="10"/>
+          </p:nvPr>
+        </p:nvSpPr>
+        <p:spPr/>
+        <p:txBody>
+          <a:bodyPr/>
+          <a:lstStyle/>
+          <a:p>
+            <a:fld id="{F7021451-1387-4CA6-816F-3879F97B5CBC}" type="slidenum">
+              <a:rPr lang="en-US"/>
+              <a:t>3</a:t>
+            </a:fld>
+            <a:endParaRPr lang="en-US"/>
+          </a:p>
+        </p:txBody>
+      </p:sp>
+    </p:spTree>
+    <p:extLst>
+      <p:ext uri="{BB962C8B-B14F-4D97-AF65-F5344CB8AC3E}">
+        <p14:creationId xmlns:p14="http://schemas.microsoft.com/office/powerpoint/2010/main" val="1024086991"/>
+      </p:ext>
+    </p:extLst>
+  </p:cSld>
+  <p:clrMapOvr>
+    <a:masterClrMapping/>
+  </p:clrMapOvr>
+</p:notes>
+</file>
+
+<file path=ppt/notesSlides/notesSlide4.xml><?xml version="1.0" encoding="utf-8"?>
+<p:notes xmlns:a="http://schemas.openxmlformats.org/drawingml/2006/main" xmlns:r="http://schemas.openxmlformats.org/officeDocument/2006/relationships" xmlns:p="http://schemas.openxmlformats.org/presentationml/2006/main">
+  <p:cSld>
+    <p:spTree>
+      <p:nvGrpSpPr>
+        <p:cNvPr id="1" name=""/>
+        <p:cNvGrpSpPr/>
+        <p:nvPr/>
+      </p:nvGrpSpPr>
+      <p:grpSpPr>
+        <a:xfrm>
+          <a:off x="0" y="0"/>
+          <a:ext cx="0" cy="0"/>
+          <a:chOff x="0" y="0"/>
+          <a:chExt cx="0" cy="0"/>
+        </a:xfrm>
+      </p:grpSpPr>
+      <p:sp>
+        <p:nvSpPr>
+          <p:cNvPr id="2" name="Slide Image Placeholder 1"/>
+          <p:cNvSpPr>
+            <a:spLocks noGrp="1" noRot="1" noChangeAspect="1"/>
+          </p:cNvSpPr>
+          <p:nvPr>
+            <p:ph type="sldImg"/>
+          </p:nvPr>
+        </p:nvSpPr>
+        <p:spPr/>
+      </p:sp>
+      <p:sp>
+        <p:nvSpPr>
+          <p:cNvPr id="3" name="Notes Placeholder 2"/>
+          <p:cNvSpPr>
+            <a:spLocks noGrp="1"/>
+          </p:cNvSpPr>
+          <p:nvPr>
+            <p:ph type="body" idx="1"/>
+          </p:nvPr>
+        </p:nvSpPr>
+        <p:spPr/>
+        <p:txBody>
+          <a:bodyPr/>
+          <a:lstStyle/>
+          <a:p>
+            <a:r>
+              <a:rPr lang="en-US" dirty="0"/>
+              <a:t/>
+            </a:r>
+            <a:endParaRPr lang="en-US" dirty="0"/>
+          </a:p>
+        </p:txBody>
+      </p:sp>
+      <p:sp>
+        <p:nvSpPr>
+          <p:cNvPr id="4" name="Slide Number Placeholder 3"/>
+          <p:cNvSpPr>
+            <a:spLocks noGrp="1"/>
+          </p:cNvSpPr>
+          <p:nvPr>
+            <p:ph type="sldNum" sz="quarter" idx="10"/>
+          </p:nvPr>
+        </p:nvSpPr>
+        <p:spPr/>
+        <p:txBody>
+          <a:bodyPr/>
+          <a:lstStyle/>
+          <a:p>
+            <a:fld id="{F7021451-1387-4CA6-816F-3879F97B5CBC}" type="slidenum">
+              <a:rPr lang="en-US"/>
+              <a:t>4</a:t>
+            </a:fld>
+            <a:endParaRPr lang="en-US"/>
+          </a:p>
+        </p:txBody>
+      </p:sp>
+    </p:spTree>
+    <p:extLst>
+      <p:ext uri="{BB962C8B-B14F-4D97-AF65-F5344CB8AC3E}">
+        <p14:creationId xmlns:p14="http://schemas.microsoft.com/office/powerpoint/2010/main" val="1024086991"/>
+      </p:ext>
+    </p:extLst>
+  </p:cSld>
+  <p:clrMapOvr>
+    <a:masterClrMapping/>
+  </p:clrMapOvr>
+</p:notes>
+</file>
+
+<file path=ppt/notesSlides/notesSlide5.xml><?xml version="1.0" encoding="utf-8"?>
+<p:notes xmlns:a="http://schemas.openxmlformats.org/drawingml/2006/main" xmlns:r="http://schemas.openxmlformats.org/officeDocument/2006/relationships" xmlns:p="http://schemas.openxmlformats.org/presentationml/2006/main">
+  <p:cSld>
+    <p:spTree>
+      <p:nvGrpSpPr>
+        <p:cNvPr id="1" name=""/>
+        <p:cNvGrpSpPr/>
+        <p:nvPr/>
+      </p:nvGrpSpPr>
+      <p:grpSpPr>
+        <a:xfrm>
+          <a:off x="0" y="0"/>
+          <a:ext cx="0" cy="0"/>
+          <a:chOff x="0" y="0"/>
+          <a:chExt cx="0" cy="0"/>
+        </a:xfrm>
+      </p:grpSpPr>
+      <p:sp>
+        <p:nvSpPr>
+          <p:cNvPr id="2" name="Slide Image Placeholder 1"/>
+          <p:cNvSpPr>
+            <a:spLocks noGrp="1" noRot="1" noChangeAspect="1"/>
+          </p:cNvSpPr>
+          <p:nvPr>
+            <p:ph type="sldImg"/>
+          </p:nvPr>
+        </p:nvSpPr>
+        <p:spPr/>
+      </p:sp>
+      <p:sp>
+        <p:nvSpPr>
+          <p:cNvPr id="3" name="Notes Placeholder 2"/>
+          <p:cNvSpPr>
+            <a:spLocks noGrp="1"/>
+          </p:cNvSpPr>
+          <p:nvPr>
+            <p:ph type="body" idx="1"/>
+          </p:nvPr>
+        </p:nvSpPr>
+        <p:spPr/>
+        <p:txBody>
+          <a:bodyPr/>
+          <a:lstStyle/>
+          <a:p>
+            <a:r>
+              <a:rPr lang="en-US" dirty="0"/>
+              <a:t/>
+            </a:r>
+            <a:endParaRPr lang="en-US" dirty="0"/>
+          </a:p>
+        </p:txBody>
+      </p:sp>
+      <p:sp>
+        <p:nvSpPr>
+          <p:cNvPr id="4" name="Slide Number Placeholder 3"/>
+          <p:cNvSpPr>
+            <a:spLocks noGrp="1"/>
+          </p:cNvSpPr>
+          <p:nvPr>
+            <p:ph type="sldNum" sz="quarter" idx="10"/>
+          </p:nvPr>
+        </p:nvSpPr>
+        <p:spPr/>
+        <p:txBody>
+          <a:bodyPr/>
+          <a:lstStyle/>
+          <a:p>
+            <a:fld id="{F7021451-1387-4CA6-816F-3879F97B5CBC}" type="slidenum">
+              <a:rPr lang="en-US"/>
+              <a:t>5</a:t>
+            </a:fld>
+            <a:endParaRPr lang="en-US"/>
+          </a:p>
+        </p:txBody>
+      </p:sp>
+    </p:spTree>
+    <p:extLst>
+      <p:ext uri="{BB962C8B-B14F-4D97-AF65-F5344CB8AC3E}">
+        <p14:creationId xmlns:p14="http://schemas.microsoft.com/office/powerpoint/2010/main" val="1024086991"/>
+      </p:ext>
+    </p:extLst>
+  </p:cSld>
+  <p:clrMapOvr>
+    <a:masterClrMapping/>
+  </p:clrMapOvr>
+</p:notes>
+</file>
+
+<file path=ppt/notesSlides/notesSlide6.xml><?xml version="1.0" encoding="utf-8"?>
+<p:notes xmlns:a="http://schemas.openxmlformats.org/drawingml/2006/main" xmlns:r="http://schemas.openxmlformats.org/officeDocument/2006/relationships" xmlns:p="http://schemas.openxmlformats.org/presentationml/2006/main">
+  <p:cSld>
+    <p:spTree>
+      <p:nvGrpSpPr>
+        <p:cNvPr id="1" name=""/>
+        <p:cNvGrpSpPr/>
+        <p:nvPr/>
+      </p:nvGrpSpPr>
+      <p:grpSpPr>
+        <a:xfrm>
+          <a:off x="0" y="0"/>
+          <a:ext cx="0" cy="0"/>
+          <a:chOff x="0" y="0"/>
+          <a:chExt cx="0" cy="0"/>
+        </a:xfrm>
+      </p:grpSpPr>
+      <p:sp>
+        <p:nvSpPr>
+          <p:cNvPr id="2" name="Slide Image Placeholder 1"/>
+          <p:cNvSpPr>
+            <a:spLocks noGrp="1" noRot="1" noChangeAspect="1"/>
+          </p:cNvSpPr>
+          <p:nvPr>
+            <p:ph type="sldImg"/>
+          </p:nvPr>
+        </p:nvSpPr>
+        <p:spPr/>
+      </p:sp>
+      <p:sp>
+        <p:nvSpPr>
+          <p:cNvPr id="3" name="Notes Placeholder 2"/>
+          <p:cNvSpPr>
+            <a:spLocks noGrp="1"/>
+          </p:cNvSpPr>
+          <p:nvPr>
+            <p:ph type="body" idx="1"/>
+          </p:nvPr>
+        </p:nvSpPr>
+        <p:spPr/>
+        <p:txBody>
+          <a:bodyPr/>
+          <a:lstStyle/>
+          <a:p>
+            <a:r>
+              <a:rPr lang="en-US" dirty="0"/>
+              <a:t/>
+            </a:r>
+            <a:endParaRPr lang="en-US" dirty="0"/>
+          </a:p>
+        </p:txBody>
+      </p:sp>
+      <p:sp>
+        <p:nvSpPr>
+          <p:cNvPr id="4" name="Slide Number Placeholder 3"/>
+          <p:cNvSpPr>
+            <a:spLocks noGrp="1"/>
+          </p:cNvSpPr>
+          <p:nvPr>
+            <p:ph type="sldNum" sz="quarter" idx="10"/>
+          </p:nvPr>
+        </p:nvSpPr>
+        <p:spPr/>
+        <p:txBody>
+          <a:bodyPr/>
+          <a:lstStyle/>
+          <a:p>
+            <a:fld id="{F7021451-1387-4CA6-816F-3879F97B5CBC}" type="slidenum">
+              <a:rPr lang="en-US"/>
+              <a:t>6</a:t>
+            </a:fld>
+            <a:endParaRPr lang="en-US"/>
+          </a:p>
+        </p:txBody>
+      </p:sp>
+    </p:spTree>
+    <p:extLst>
+      <p:ext uri="{BB962C8B-B14F-4D97-AF65-F5344CB8AC3E}">
+        <p14:creationId xmlns:p14="http://schemas.microsoft.com/office/powerpoint/2010/main" val="1024086991"/>
+      </p:ext>
+    </p:extLst>
+  </p:cSld>
+  <p:clrMapOvr>
+    <a:masterClrMapping/>
+  </p:clrMapOvr>
+</p:notes>
+</file>
+
+<file path=ppt/notesSlides/notesSlide7.xml><?xml version="1.0" encoding="utf-8"?>
+<p:notes xmlns:a="http://schemas.openxmlformats.org/drawingml/2006/main" xmlns:r="http://schemas.openxmlformats.org/officeDocument/2006/relationships" xmlns:p="http://schemas.openxmlformats.org/presentationml/2006/main">
+  <p:cSld>
+    <p:spTree>
+      <p:nvGrpSpPr>
+        <p:cNvPr id="1" name=""/>
+        <p:cNvGrpSpPr/>
+        <p:nvPr/>
+      </p:nvGrpSpPr>
+      <p:grpSpPr>
+        <a:xfrm>
+          <a:off x="0" y="0"/>
+          <a:ext cx="0" cy="0"/>
+          <a:chOff x="0" y="0"/>
+          <a:chExt cx="0" cy="0"/>
+        </a:xfrm>
+      </p:grpSpPr>
+      <p:sp>
+        <p:nvSpPr>
+          <p:cNvPr id="2" name="Slide Image Placeholder 1"/>
+          <p:cNvSpPr>
+            <a:spLocks noGrp="1" noRot="1" noChangeAspect="1"/>
+          </p:cNvSpPr>
+          <p:nvPr>
+            <p:ph type="sldImg"/>
+          </p:nvPr>
+        </p:nvSpPr>
+        <p:spPr/>
+      </p:sp>
+      <p:sp>
+        <p:nvSpPr>
+          <p:cNvPr id="3" name="Notes Placeholder 2"/>
+          <p:cNvSpPr>
+            <a:spLocks noGrp="1"/>
+          </p:cNvSpPr>
+          <p:nvPr>
+            <p:ph type="body" idx="1"/>
+          </p:nvPr>
+        </p:nvSpPr>
+        <p:spPr/>
+        <p:txBody>
+          <a:bodyPr/>
+          <a:lstStyle/>
+          <a:p>
+            <a:r>
+              <a:rPr lang="en-US" dirty="0"/>
+              <a:t/>
+            </a:r>
+            <a:endParaRPr lang="en-US" dirty="0"/>
+          </a:p>
+        </p:txBody>
+      </p:sp>
+      <p:sp>
+        <p:nvSpPr>
+          <p:cNvPr id="4" name="Slide Number Placeholder 3"/>
+          <p:cNvSpPr>
+            <a:spLocks noGrp="1"/>
+          </p:cNvSpPr>
+          <p:nvPr>
+            <p:ph type="sldNum" sz="quarter" idx="10"/>
+          </p:nvPr>
+        </p:nvSpPr>
+        <p:spPr/>
+        <p:txBody>
+          <a:bodyPr/>
+          <a:lstStyle/>
+          <a:p>
+            <a:fld id="{F7021451-1387-4CA6-816F-3879F97B5CBC}" type="slidenum">
+              <a:rPr lang="en-US"/>
+              <a:t>7</a:t>
+            </a:fld>
+            <a:endParaRPr lang="en-US"/>
+          </a:p>
+        </p:txBody>
+      </p:sp>
+    </p:spTree>
+    <p:extLst>
+      <p:ext uri="{BB962C8B-B14F-4D97-AF65-F5344CB8AC3E}">
+        <p14:creationId xmlns:p14="http://schemas.microsoft.com/office/powerpoint/2010/main" val="1024086991"/>
+      </p:ext>
+    </p:extLst>
+  </p:cSld>
+  <p:clrMapOvr>
+    <a:masterClrMapping/>
+  </p:clrMapOvr>
+</p:notes>
+</file>
+
+<file path=ppt/notesSlides/notesSlide8.xml><?xml version="1.0" encoding="utf-8"?>
+<p:notes xmlns:a="http://schemas.openxmlformats.org/drawingml/2006/main" xmlns:r="http://schemas.openxmlformats.org/officeDocument/2006/relationships" xmlns:p="http://schemas.openxmlformats.org/presentationml/2006/main">
+  <p:cSld>
+    <p:spTree>
+      <p:nvGrpSpPr>
+        <p:cNvPr id="1" name=""/>
+        <p:cNvGrpSpPr/>
+        <p:nvPr/>
+      </p:nvGrpSpPr>
+      <p:grpSpPr>
+        <a:xfrm>
+          <a:off x="0" y="0"/>
+          <a:ext cx="0" cy="0"/>
+          <a:chOff x="0" y="0"/>
+          <a:chExt cx="0" cy="0"/>
+        </a:xfrm>
+      </p:grpSpPr>
+      <p:sp>
+        <p:nvSpPr>
+          <p:cNvPr id="2" name="Slide Image Placeholder 1"/>
+          <p:cNvSpPr>
+            <a:spLocks noGrp="1" noRot="1" noChangeAspect="1"/>
+          </p:cNvSpPr>
+          <p:nvPr>
+            <p:ph type="sldImg"/>
+          </p:nvPr>
+        </p:nvSpPr>
+        <p:spPr/>
+      </p:sp>
+      <p:sp>
+        <p:nvSpPr>
+          <p:cNvPr id="3" name="Notes Placeholder 2"/>
+          <p:cNvSpPr>
+            <a:spLocks noGrp="1"/>
+          </p:cNvSpPr>
+          <p:nvPr>
+            <p:ph type="body" idx="1"/>
+          </p:nvPr>
+        </p:nvSpPr>
+        <p:spPr/>
+        <p:txBody>
+          <a:bodyPr/>
+          <a:lstStyle/>
+          <a:p>
+            <a:r>
+              <a:rPr lang="en-US" dirty="0"/>
+              <a:t/>
+            </a:r>
+            <a:endParaRPr lang="en-US" dirty="0"/>
+          </a:p>
+        </p:txBody>
+      </p:sp>
+      <p:sp>
+        <p:nvSpPr>
+          <p:cNvPr id="4" name="Slide Number Placeholder 3"/>
+          <p:cNvSpPr>
+            <a:spLocks noGrp="1"/>
+          </p:cNvSpPr>
+          <p:nvPr>
+            <p:ph type="sldNum" sz="quarter" idx="10"/>
+          </p:nvPr>
+        </p:nvSpPr>
+        <p:spPr/>
+        <p:txBody>
+          <a:bodyPr/>
+          <a:lstStyle/>
+          <a:p>
+            <a:fld id="{F7021451-1387-4CA6-816F-3879F97B5CBC}" type="slidenum">
+              <a:rPr lang="en-US"/>
+              <a:t>8</a:t>
+            </a:fld>
+            <a:endParaRPr lang="en-US"/>
+          </a:p>
+        </p:txBody>
+      </p:sp>
+    </p:spTree>
+    <p:extLst>
+      <p:ext uri="{BB962C8B-B14F-4D97-AF65-F5344CB8AC3E}">
+        <p14:creationId xmlns:p14="http://schemas.microsoft.com/office/powerpoint/2010/main" val="1024086991"/>
+      </p:ext>
+    </p:extLst>
+  </p:cSld>
+  <p:clrMapOvr>
+    <a:masterClrMapping/>
+  </p:clrMapOvr>
+</p:notes>
+</file>
+
+<file path=ppt/notesSlides/notesSlide9.xml><?xml version="1.0" encoding="utf-8"?>
+<p:notes xmlns:a="http://schemas.openxmlformats.org/drawingml/2006/main" xmlns:r="http://schemas.openxmlformats.org/officeDocument/2006/relationships" xmlns:p="http://schemas.openxmlformats.org/presentationml/2006/main">
+  <p:cSld>
+    <p:spTree>
+      <p:nvGrpSpPr>
+        <p:cNvPr id="1" name=""/>
+        <p:cNvGrpSpPr/>
+        <p:nvPr/>
+      </p:nvGrpSpPr>
+      <p:grpSpPr>
+        <a:xfrm>
+          <a:off x="0" y="0"/>
+          <a:ext cx="0" cy="0"/>
+          <a:chOff x="0" y="0"/>
+          <a:chExt cx="0" cy="0"/>
+        </a:xfrm>
+      </p:grpSpPr>
+      <p:sp>
+        <p:nvSpPr>
+          <p:cNvPr id="2" name="Slide Image Placeholder 1"/>
+          <p:cNvSpPr>
+            <a:spLocks noGrp="1" noRot="1" noChangeAspect="1"/>
+          </p:cNvSpPr>
+          <p:nvPr>
+            <p:ph type="sldImg"/>
+          </p:nvPr>
+        </p:nvSpPr>
+        <p:spPr/>
+      </p:sp>
+      <p:sp>
+        <p:nvSpPr>
+          <p:cNvPr id="3" name="Notes Placeholder 2"/>
+          <p:cNvSpPr>
+            <a:spLocks noGrp="1"/>
+          </p:cNvSpPr>
+          <p:nvPr>
+            <p:ph type="body" idx="1"/>
+          </p:nvPr>
+        </p:nvSpPr>
+        <p:spPr/>
+        <p:txBody>
+          <a:bodyPr/>
+          <a:lstStyle/>
+          <a:p>
+            <a:r>
+              <a:rPr lang="en-US" dirty="0"/>
+              <a:t/>
+            </a:r>
+            <a:endParaRPr lang="en-US" dirty="0"/>
+          </a:p>
+        </p:txBody>
+      </p:sp>
+      <p:sp>
+        <p:nvSpPr>
+          <p:cNvPr id="4" name="Slide Number Placeholder 3"/>
+          <p:cNvSpPr>
+            <a:spLocks noGrp="1"/>
+          </p:cNvSpPr>
+          <p:nvPr>
+            <p:ph type="sldNum" sz="quarter" idx="10"/>
+          </p:nvPr>
+        </p:nvSpPr>
+        <p:spPr/>
+        <p:txBody>
+          <a:bodyPr/>
+          <a:lstStyle/>
+          <a:p>
+            <a:fld id="{F7021451-1387-4CA6-816F-3879F97B5CBC}" type="slidenum">
+              <a:rPr lang="en-US"/>
+              <a:t>9</a:t>
+            </a:fld>
+            <a:endParaRPr lang="en-US"/>
+          </a:p>
+        </p:txBody>
+      </p:sp>
+    </p:spTree>
+    <p:extLst>
+      <p:ext uri="{BB962C8B-B14F-4D97-AF65-F5344CB8AC3E}">
+        <p14:creationId xmlns:p14="http://schemas.microsoft.com/office/powerpoint/2010/main" val="1024086991"/>
+      </p:ext>
+    </p:extLst>
+  </p:cSld>
+  <p:clrMapOvr>
+    <a:masterClrMapping/>
+  </p:clrMapOvr>
+</p:notes>
 </file>
 
 <file path=ppt/slideLayouts/slideLayout1.xml><?xml version="1.0" encoding="utf-8"?>
@@ -761,6 +1652,2008 @@
 </p:sldMaster>
 </file>
 
+<file path=ppt/slides/slide1.xml><?xml version="1.0" encoding="utf-8"?>
+<p:sld xmlns:a="http://schemas.openxmlformats.org/drawingml/2006/main" xmlns:r="http://schemas.openxmlformats.org/officeDocument/2006/relationships" xmlns:p="http://schemas.openxmlformats.org/presentationml/2006/main">
+  <p:cSld name="Slide 1">
+    <p:bg>
+      <p:bgPr>
+        <a:blipFill dpi="0" rotWithShape="1">
+          <a:blip r:embed="rId1">
+            <a:lum/>
+          </a:blip>
+          <a:srcRect/>
+          <a:stretch>
+            <a:fillRect/>
+          </a:stretch>
+        </a:blipFill>
+        <a:effectLst/>
+      </p:bgPr>
+    </p:bg>
+    <p:spTree>
+      <p:nvGrpSpPr>
+        <p:cNvPr id="1" name=""/>
+        <p:cNvGrpSpPr/>
+        <p:nvPr/>
+      </p:nvGrpSpPr>
+      <p:grpSpPr>
+        <a:xfrm>
+          <a:off x="0" y="0"/>
+          <a:ext cx="0" cy="0"/>
+          <a:chOff x="0" y="0"/>
+          <a:chExt cx="0" cy="0"/>
+        </a:xfrm>
+      </p:grpSpPr>
+      <p:sp>
+        <p:nvSpPr>
+          <p:cNvPr id="2" name="Text 0"/>
+          <p:cNvSpPr/>
+          <p:nvPr/>
+        </p:nvSpPr>
+        <p:spPr>
+          <a:xfrm>
+            <a:off x="457200" y="457200"/>
+            <a:ext cx="8229600" cy="914400"/>
+          </a:xfrm>
+          <a:prstGeom prst="rect">
+            <a:avLst/>
+          </a:prstGeom>
+          <a:noFill/>
+          <a:ln/>
+        </p:spPr>
+        <p:txBody>
+          <a:bodyPr wrap="square" rtlCol="0" anchor="ctr"/>
+          <a:lstStyle/>
+          <a:p>
+            <a:pPr algn="l" indent="0" marL="0">
+              <a:buNone/>
+            </a:pPr>
+            <a:r>
+              <a:rPr lang="en-US" sz="4400" b="1" dirty="0">
+                <a:solidFill>
+                  <a:srgbClr val="17406D"/>
+                </a:solidFill>
+                <a:latin typeface="Arial" pitchFamily="34" charset="0"/>
+                <a:ea typeface="Arial" pitchFamily="34" charset="-122"/>
+                <a:cs typeface="Arial" pitchFamily="34" charset="-120"/>
+              </a:rPr>
+              <a:t>沈阳医学院附属中心医院</a:t>
+            </a:r>
+            <a:endParaRPr lang="en-US" sz="4400" dirty="0"/>
+          </a:p>
+        </p:txBody>
+      </p:sp>
+      <p:sp>
+        <p:nvSpPr>
+          <p:cNvPr id="3" name="Text 1"/>
+          <p:cNvSpPr/>
+          <p:nvPr/>
+        </p:nvSpPr>
+        <p:spPr>
+          <a:xfrm>
+            <a:off x="457200" y="1645920"/>
+            <a:ext cx="8229600" cy="731520"/>
+          </a:xfrm>
+          <a:prstGeom prst="rect">
+            <a:avLst/>
+          </a:prstGeom>
+          <a:noFill/>
+          <a:ln/>
+        </p:spPr>
+        <p:txBody>
+          <a:bodyPr wrap="square" rtlCol="0" anchor="ctr"/>
+          <a:lstStyle/>
+          <a:p>
+            <a:pPr algn="l" indent="0" marL="0">
+              <a:buNone/>
+            </a:pPr>
+            <a:r>
+              <a:rPr lang="en-US" sz="2400" dirty="0">
+                <a:solidFill>
+                  <a:srgbClr val="009DD9"/>
+                </a:solidFill>
+                <a:latin typeface="Arial" pitchFamily="34" charset="0"/>
+                <a:ea typeface="Arial" pitchFamily="34" charset="-122"/>
+                <a:cs typeface="Arial" pitchFamily="34" charset="-120"/>
+              </a:rPr>
+              <a:t>数智病理科建设方案</a:t>
+            </a:r>
+            <a:endParaRPr lang="en-US" sz="2400" dirty="0"/>
+          </a:p>
+        </p:txBody>
+      </p:sp>
+      <p:sp>
+        <p:nvSpPr>
+          <p:cNvPr id="4" name="Text 2"/>
+          <p:cNvSpPr/>
+          <p:nvPr/>
+        </p:nvSpPr>
+        <p:spPr>
+          <a:xfrm>
+            <a:off x="457200" y="2560320"/>
+            <a:ext cx="8229600" cy="2743200"/>
+          </a:xfrm>
+          <a:prstGeom prst="rect">
+            <a:avLst/>
+          </a:prstGeom>
+          <a:noFill/>
+          <a:ln/>
+        </p:spPr>
+        <p:txBody>
+          <a:bodyPr wrap="square" rtlCol="0" anchor="t"/>
+          <a:lstStyle/>
+          <a:p>
+            <a:pPr algn="l" indent="0" marL="0">
+              <a:buNone/>
+            </a:pPr>
+            <a:r>
+              <a:rPr lang="en-US" sz="1800" dirty="0">
+                <a:solidFill>
+                  <a:srgbClr val="17406D"/>
+                </a:solidFill>
+                <a:latin typeface="Arial" pitchFamily="34" charset="0"/>
+                <a:ea typeface="Arial" pitchFamily="34" charset="-122"/>
+                <a:cs typeface="Arial" pitchFamily="34" charset="-120"/>
+              </a:rPr>
+              <a:t>项目背景</a:t>
+            </a:r>
+            <a:endParaRPr lang="en-US" sz="1800" dirty="0"/>
+          </a:p>
+          <a:p>
+            <a:pPr algn="l" indent="0" marL="0">
+              <a:buNone/>
+            </a:pPr>
+            <a:r>
+              <a:rPr lang="en-US" sz="1800" dirty="0">
+                <a:solidFill>
+                  <a:srgbClr val="17406D"/>
+                </a:solidFill>
+                <a:latin typeface="Arial" pitchFamily="34" charset="0"/>
+                <a:ea typeface="Arial" pitchFamily="34" charset="-122"/>
+                <a:cs typeface="Arial" pitchFamily="34" charset="-120"/>
+              </a:rPr>
+              <a:t>建设目标</a:t>
+            </a:r>
+            <a:endParaRPr lang="en-US" sz="1800" dirty="0"/>
+          </a:p>
+          <a:p>
+            <a:pPr algn="l" indent="0" marL="0">
+              <a:buNone/>
+            </a:pPr>
+            <a:r>
+              <a:rPr lang="en-US" sz="1800" dirty="0">
+                <a:solidFill>
+                  <a:srgbClr val="17406D"/>
+                </a:solidFill>
+                <a:latin typeface="Arial" pitchFamily="34" charset="0"/>
+                <a:ea typeface="Arial" pitchFamily="34" charset="-122"/>
+                <a:cs typeface="Arial" pitchFamily="34" charset="-120"/>
+              </a:rPr>
+              <a:t>技术方案</a:t>
+            </a:r>
+            <a:endParaRPr lang="en-US" sz="1800" dirty="0"/>
+          </a:p>
+        </p:txBody>
+      </p:sp>
+    </p:spTree>
+  </p:cSld>
+  <p:clrMapOvr>
+    <a:masterClrMapping/>
+  </p:clrMapOvr>
+</p:sld>
+</file>
+
+<file path=ppt/slides/slide10.xml><?xml version="1.0" encoding="utf-8"?>
+<p:sld xmlns:a="http://schemas.openxmlformats.org/drawingml/2006/main" xmlns:r="http://schemas.openxmlformats.org/officeDocument/2006/relationships" xmlns:p="http://schemas.openxmlformats.org/presentationml/2006/main">
+  <p:cSld name="Slide 10">
+    <p:bg>
+      <p:bgPr>
+        <a:blipFill dpi="0" rotWithShape="1">
+          <a:blip r:embed="rId1">
+            <a:lum/>
+          </a:blip>
+          <a:srcRect/>
+          <a:stretch>
+            <a:fillRect/>
+          </a:stretch>
+        </a:blipFill>
+        <a:effectLst/>
+      </p:bgPr>
+    </p:bg>
+    <p:spTree>
+      <p:nvGrpSpPr>
+        <p:cNvPr id="1" name=""/>
+        <p:cNvGrpSpPr/>
+        <p:nvPr/>
+      </p:nvGrpSpPr>
+      <p:grpSpPr>
+        <a:xfrm>
+          <a:off x="0" y="0"/>
+          <a:ext cx="0" cy="0"/>
+          <a:chOff x="0" y="0"/>
+          <a:chExt cx="0" cy="0"/>
+        </a:xfrm>
+      </p:grpSpPr>
+      <p:sp>
+        <p:nvSpPr>
+          <p:cNvPr id="2" name="Text 0"/>
+          <p:cNvSpPr/>
+          <p:nvPr/>
+        </p:nvSpPr>
+        <p:spPr>
+          <a:xfrm>
+            <a:off x="457200" y="457200"/>
+            <a:ext cx="8229600" cy="914400"/>
+          </a:xfrm>
+          <a:prstGeom prst="rect">
+            <a:avLst/>
+          </a:prstGeom>
+          <a:noFill/>
+          <a:ln/>
+        </p:spPr>
+        <p:txBody>
+          <a:bodyPr wrap="square" rtlCol="0" anchor="ctr"/>
+          <a:lstStyle/>
+          <a:p>
+            <a:pPr algn="l" indent="0" marL="0">
+              <a:buNone/>
+            </a:pPr>
+            <a:r>
+              <a:rPr lang="en-US" sz="4400" b="1" dirty="0">
+                <a:solidFill>
+                  <a:srgbClr val="17406D"/>
+                </a:solidFill>
+                <a:latin typeface="Arial" pitchFamily="34" charset="0"/>
+                <a:ea typeface="Arial" pitchFamily="34" charset="-122"/>
+                <a:cs typeface="Arial" pitchFamily="34" charset="-120"/>
+              </a:rPr>
+              <a:t>Thank You</a:t>
+            </a:r>
+            <a:endParaRPr lang="en-US" sz="4400" dirty="0"/>
+          </a:p>
+        </p:txBody>
+      </p:sp>
+      <p:sp>
+        <p:nvSpPr>
+          <p:cNvPr id="3" name="Text 1"/>
+          <p:cNvSpPr/>
+          <p:nvPr/>
+        </p:nvSpPr>
+        <p:spPr>
+          <a:xfrm>
+            <a:off x="457200" y="1645920"/>
+            <a:ext cx="8229600" cy="731520"/>
+          </a:xfrm>
+          <a:prstGeom prst="rect">
+            <a:avLst/>
+          </a:prstGeom>
+          <a:noFill/>
+          <a:ln/>
+        </p:spPr>
+        <p:txBody>
+          <a:bodyPr wrap="square" rtlCol="0" anchor="ctr"/>
+          <a:lstStyle/>
+          <a:p>
+            <a:pPr algn="l" indent="0" marL="0">
+              <a:buNone/>
+            </a:pPr>
+            <a:r>
+              <a:rPr lang="en-US" sz="2400" dirty="0">
+                <a:solidFill>
+                  <a:srgbClr val="009DD9"/>
+                </a:solidFill>
+                <a:latin typeface="Arial" pitchFamily="34" charset="0"/>
+                <a:ea typeface="Arial" pitchFamily="34" charset="-122"/>
+                <a:cs typeface="Arial" pitchFamily="34" charset="-120"/>
+              </a:rPr>
+              <a:t>感谢聆听</a:t>
+            </a:r>
+            <a:endParaRPr lang="en-US" sz="2400" dirty="0"/>
+          </a:p>
+        </p:txBody>
+      </p:sp>
+      <p:sp>
+        <p:nvSpPr>
+          <p:cNvPr id="4" name="Text 2"/>
+          <p:cNvSpPr/>
+          <p:nvPr/>
+        </p:nvSpPr>
+        <p:spPr>
+          <a:xfrm>
+            <a:off x="457200" y="2560320"/>
+            <a:ext cx="8229600" cy="2743200"/>
+          </a:xfrm>
+          <a:prstGeom prst="rect">
+            <a:avLst/>
+          </a:prstGeom>
+          <a:noFill/>
+          <a:ln/>
+        </p:spPr>
+        <p:txBody>
+          <a:bodyPr wrap="square" rtlCol="0" anchor="t"/>
+          <a:lstStyle/>
+          <a:p>
+            <a:pPr algn="l" indent="0" marL="0">
+              <a:buNone/>
+            </a:pPr>
+            <a:r>
+              <a:rPr lang="en-US" sz="1800" dirty="0">
+                <a:solidFill>
+                  <a:srgbClr val="17406D"/>
+                </a:solidFill>
+                <a:latin typeface="Arial" pitchFamily="34" charset="0"/>
+                <a:ea typeface="Arial" pitchFamily="34" charset="-122"/>
+                <a:cs typeface="Arial" pitchFamily="34" charset="-120"/>
+              </a:rPr>
+              <a:t>联系我们</a:t>
+            </a:r>
+            <a:endParaRPr lang="en-US" sz="1800" dirty="0"/>
+          </a:p>
+          <a:p>
+            <a:pPr algn="l" indent="0" marL="0">
+              <a:buNone/>
+            </a:pPr>
+            <a:r>
+              <a:rPr lang="en-US" sz="1800" dirty="0">
+                <a:solidFill>
+                  <a:srgbClr val="17406D"/>
+                </a:solidFill>
+                <a:latin typeface="Arial" pitchFamily="34" charset="0"/>
+                <a:ea typeface="Arial" pitchFamily="34" charset="-122"/>
+                <a:cs typeface="Arial" pitchFamily="34" charset="-120"/>
+              </a:rPr>
+              <a:t>谢谢！</a:t>
+            </a:r>
+            <a:endParaRPr lang="en-US" sz="1800" dirty="0"/>
+          </a:p>
+        </p:txBody>
+      </p:sp>
+    </p:spTree>
+  </p:cSld>
+  <p:clrMapOvr>
+    <a:masterClrMapping/>
+  </p:clrMapOvr>
+</p:sld>
+</file>
+
+<file path=ppt/slides/slide2.xml><?xml version="1.0" encoding="utf-8"?>
+<p:sld xmlns:a="http://schemas.openxmlformats.org/drawingml/2006/main" xmlns:r="http://schemas.openxmlformats.org/officeDocument/2006/relationships" xmlns:p="http://schemas.openxmlformats.org/presentationml/2006/main">
+  <p:cSld name="Slide 2">
+    <p:bg>
+      <p:bgPr>
+        <a:blipFill dpi="0" rotWithShape="1">
+          <a:blip r:embed="rId1">
+            <a:lum/>
+          </a:blip>
+          <a:srcRect/>
+          <a:stretch>
+            <a:fillRect/>
+          </a:stretch>
+        </a:blipFill>
+        <a:effectLst/>
+      </p:bgPr>
+    </p:bg>
+    <p:spTree>
+      <p:nvGrpSpPr>
+        <p:cNvPr id="1" name=""/>
+        <p:cNvGrpSpPr/>
+        <p:nvPr/>
+      </p:nvGrpSpPr>
+      <p:grpSpPr>
+        <a:xfrm>
+          <a:off x="0" y="0"/>
+          <a:ext cx="0" cy="0"/>
+          <a:chOff x="0" y="0"/>
+          <a:chExt cx="0" cy="0"/>
+        </a:xfrm>
+      </p:grpSpPr>
+      <p:sp>
+        <p:nvSpPr>
+          <p:cNvPr id="2" name="Text 0"/>
+          <p:cNvSpPr/>
+          <p:nvPr/>
+        </p:nvSpPr>
+        <p:spPr>
+          <a:xfrm>
+            <a:off x="457200" y="457200"/>
+            <a:ext cx="8229600" cy="914400"/>
+          </a:xfrm>
+          <a:prstGeom prst="rect">
+            <a:avLst/>
+          </a:prstGeom>
+          <a:noFill/>
+          <a:ln/>
+        </p:spPr>
+        <p:txBody>
+          <a:bodyPr wrap="square" rtlCol="0" anchor="ctr"/>
+          <a:lstStyle/>
+          <a:p>
+            <a:pPr algn="l" indent="0" marL="0">
+              <a:buNone/>
+            </a:pPr>
+            <a:r>
+              <a:rPr lang="en-US" sz="4400" b="1" dirty="0">
+                <a:solidFill>
+                  <a:srgbClr val="17406D"/>
+                </a:solidFill>
+                <a:latin typeface="Arial" pitchFamily="34" charset="0"/>
+                <a:ea typeface="Arial" pitchFamily="34" charset="-122"/>
+                <a:cs typeface="Arial" pitchFamily="34" charset="-120"/>
+              </a:rPr>
+              <a:t>Agenda</a:t>
+            </a:r>
+            <a:endParaRPr lang="en-US" sz="4400" dirty="0"/>
+          </a:p>
+        </p:txBody>
+      </p:sp>
+      <p:sp>
+        <p:nvSpPr>
+          <p:cNvPr id="3" name="Text 1"/>
+          <p:cNvSpPr/>
+          <p:nvPr/>
+        </p:nvSpPr>
+        <p:spPr>
+          <a:xfrm>
+            <a:off x="457200" y="1645920"/>
+            <a:ext cx="8229600" cy="731520"/>
+          </a:xfrm>
+          <a:prstGeom prst="rect">
+            <a:avLst/>
+          </a:prstGeom>
+          <a:noFill/>
+          <a:ln/>
+        </p:spPr>
+        <p:txBody>
+          <a:bodyPr wrap="square" rtlCol="0" anchor="ctr"/>
+          <a:lstStyle/>
+          <a:p>
+            <a:pPr algn="l" indent="0" marL="0">
+              <a:buNone/>
+            </a:pPr>
+            <a:r>
+              <a:rPr lang="en-US" sz="2400" dirty="0">
+                <a:solidFill>
+                  <a:srgbClr val="009DD9"/>
+                </a:solidFill>
+                <a:latin typeface="Arial" pitchFamily="34" charset="0"/>
+                <a:ea typeface="Arial" pitchFamily="34" charset="-122"/>
+                <a:cs typeface="Arial" pitchFamily="34" charset="-120"/>
+              </a:rPr>
+              <a:t>汇报提纲</a:t>
+            </a:r>
+            <a:endParaRPr lang="en-US" sz="2400" dirty="0"/>
+          </a:p>
+        </p:txBody>
+      </p:sp>
+      <p:sp>
+        <p:nvSpPr>
+          <p:cNvPr id="4" name="Text 2"/>
+          <p:cNvSpPr/>
+          <p:nvPr/>
+        </p:nvSpPr>
+        <p:spPr>
+          <a:xfrm>
+            <a:off x="457200" y="2560320"/>
+            <a:ext cx="8229600" cy="2743200"/>
+          </a:xfrm>
+          <a:prstGeom prst="rect">
+            <a:avLst/>
+          </a:prstGeom>
+          <a:noFill/>
+          <a:ln/>
+        </p:spPr>
+        <p:txBody>
+          <a:bodyPr wrap="square" rtlCol="0" anchor="t"/>
+          <a:lstStyle/>
+          <a:p>
+            <a:pPr algn="l" indent="0" marL="0">
+              <a:buNone/>
+            </a:pPr>
+            <a:r>
+              <a:rPr lang="en-US" sz="1800" dirty="0">
+                <a:solidFill>
+                  <a:srgbClr val="17406D"/>
+                </a:solidFill>
+                <a:latin typeface="Arial" pitchFamily="34" charset="0"/>
+                <a:ea typeface="Arial" pitchFamily="34" charset="-122"/>
+                <a:cs typeface="Arial" pitchFamily="34" charset="-120"/>
+              </a:rPr>
+              <a:t>项目背景与需求</a:t>
+            </a:r>
+            <a:endParaRPr lang="en-US" sz="1800" dirty="0"/>
+          </a:p>
+          <a:p>
+            <a:pPr algn="l" indent="0" marL="0">
+              <a:buNone/>
+            </a:pPr>
+            <a:r>
+              <a:rPr lang="en-US" sz="1800" dirty="0">
+                <a:solidFill>
+                  <a:srgbClr val="17406D"/>
+                </a:solidFill>
+                <a:latin typeface="Arial" pitchFamily="34" charset="0"/>
+                <a:ea typeface="Arial" pitchFamily="34" charset="-122"/>
+                <a:cs typeface="Arial" pitchFamily="34" charset="-120"/>
+              </a:rPr>
+              <a:t>建设目标与方案</a:t>
+            </a:r>
+            <a:endParaRPr lang="en-US" sz="1800" dirty="0"/>
+          </a:p>
+          <a:p>
+            <a:pPr algn="l" indent="0" marL="0">
+              <a:buNone/>
+            </a:pPr>
+            <a:r>
+              <a:rPr lang="en-US" sz="1800" dirty="0">
+                <a:solidFill>
+                  <a:srgbClr val="17406D"/>
+                </a:solidFill>
+                <a:latin typeface="Arial" pitchFamily="34" charset="0"/>
+                <a:ea typeface="Arial" pitchFamily="34" charset="-122"/>
+                <a:cs typeface="Arial" pitchFamily="34" charset="-120"/>
+              </a:rPr>
+              <a:t>技术架构设计</a:t>
+            </a:r>
+            <a:endParaRPr lang="en-US" sz="1800" dirty="0"/>
+          </a:p>
+          <a:p>
+            <a:pPr algn="l" indent="0" marL="0">
+              <a:buNone/>
+            </a:pPr>
+            <a:r>
+              <a:rPr lang="en-US" sz="1800" dirty="0">
+                <a:solidFill>
+                  <a:srgbClr val="17406D"/>
+                </a:solidFill>
+                <a:latin typeface="Arial" pitchFamily="34" charset="0"/>
+                <a:ea typeface="Arial" pitchFamily="34" charset="-122"/>
+                <a:cs typeface="Arial" pitchFamily="34" charset="-120"/>
+              </a:rPr>
+              <a:t>实施计划与预期效益</a:t>
+            </a:r>
+            <a:endParaRPr lang="en-US" sz="1800" dirty="0"/>
+          </a:p>
+        </p:txBody>
+      </p:sp>
+    </p:spTree>
+  </p:cSld>
+  <p:clrMapOvr>
+    <a:masterClrMapping/>
+  </p:clrMapOvr>
+</p:sld>
+</file>
+
+<file path=ppt/slides/slide3.xml><?xml version="1.0" encoding="utf-8"?>
+<p:sld xmlns:a="http://schemas.openxmlformats.org/drawingml/2006/main" xmlns:r="http://schemas.openxmlformats.org/officeDocument/2006/relationships" xmlns:p="http://schemas.openxmlformats.org/presentationml/2006/main">
+  <p:cSld name="Slide 3">
+    <p:bg>
+      <p:bgPr>
+        <a:blipFill dpi="0" rotWithShape="1">
+          <a:blip r:embed="rId1">
+            <a:lum/>
+          </a:blip>
+          <a:srcRect/>
+          <a:stretch>
+            <a:fillRect/>
+          </a:stretch>
+        </a:blipFill>
+        <a:effectLst/>
+      </p:bgPr>
+    </p:bg>
+    <p:spTree>
+      <p:nvGrpSpPr>
+        <p:cNvPr id="1" name=""/>
+        <p:cNvGrpSpPr/>
+        <p:nvPr/>
+      </p:nvGrpSpPr>
+      <p:grpSpPr>
+        <a:xfrm>
+          <a:off x="0" y="0"/>
+          <a:ext cx="0" cy="0"/>
+          <a:chOff x="0" y="0"/>
+          <a:chExt cx="0" cy="0"/>
+        </a:xfrm>
+      </p:grpSpPr>
+      <p:sp>
+        <p:nvSpPr>
+          <p:cNvPr id="2" name="Text 0"/>
+          <p:cNvSpPr/>
+          <p:nvPr/>
+        </p:nvSpPr>
+        <p:spPr>
+          <a:xfrm>
+            <a:off x="457200" y="457200"/>
+            <a:ext cx="8229600" cy="914400"/>
+          </a:xfrm>
+          <a:prstGeom prst="rect">
+            <a:avLst/>
+          </a:prstGeom>
+          <a:noFill/>
+          <a:ln/>
+        </p:spPr>
+        <p:txBody>
+          <a:bodyPr wrap="square" rtlCol="0" anchor="ctr"/>
+          <a:lstStyle/>
+          <a:p>
+            <a:pPr algn="l" indent="0" marL="0">
+              <a:buNone/>
+            </a:pPr>
+            <a:r>
+              <a:rPr lang="en-US" sz="4400" b="1" dirty="0">
+                <a:solidFill>
+                  <a:srgbClr val="17406D"/>
+                </a:solidFill>
+                <a:latin typeface="Arial" pitchFamily="34" charset="0"/>
+                <a:ea typeface="Arial" pitchFamily="34" charset="-122"/>
+                <a:cs typeface="Arial" pitchFamily="34" charset="-120"/>
+              </a:rPr>
+              <a:t>项目背景</a:t>
+            </a:r>
+            <a:endParaRPr lang="en-US" sz="4400" dirty="0"/>
+          </a:p>
+        </p:txBody>
+      </p:sp>
+      <p:sp>
+        <p:nvSpPr>
+          <p:cNvPr id="3" name="Text 1"/>
+          <p:cNvSpPr/>
+          <p:nvPr/>
+        </p:nvSpPr>
+        <p:spPr>
+          <a:xfrm>
+            <a:off x="457200" y="1645920"/>
+            <a:ext cx="8229600" cy="731520"/>
+          </a:xfrm>
+          <a:prstGeom prst="rect">
+            <a:avLst/>
+          </a:prstGeom>
+          <a:noFill/>
+          <a:ln/>
+        </p:spPr>
+        <p:txBody>
+          <a:bodyPr wrap="square" rtlCol="0" anchor="ctr"/>
+          <a:lstStyle/>
+          <a:p>
+            <a:pPr algn="l" indent="0" marL="0">
+              <a:buNone/>
+            </a:pPr>
+            <a:r>
+              <a:rPr lang="en-US" sz="2400" dirty="0">
+                <a:solidFill>
+                  <a:srgbClr val="009DD9"/>
+                </a:solidFill>
+                <a:latin typeface="Arial" pitchFamily="34" charset="0"/>
+                <a:ea typeface="Arial" pitchFamily="34" charset="-122"/>
+                <a:cs typeface="Arial" pitchFamily="34" charset="-120"/>
+              </a:rPr>
+              <a:t>提升病理诊断效率与准确性</a:t>
+            </a:r>
+            <a:endParaRPr lang="en-US" sz="2400" dirty="0"/>
+          </a:p>
+        </p:txBody>
+      </p:sp>
+      <p:sp>
+        <p:nvSpPr>
+          <p:cNvPr id="4" name="Text 2"/>
+          <p:cNvSpPr/>
+          <p:nvPr/>
+        </p:nvSpPr>
+        <p:spPr>
+          <a:xfrm>
+            <a:off x="457200" y="2560320"/>
+            <a:ext cx="8229600" cy="2743200"/>
+          </a:xfrm>
+          <a:prstGeom prst="rect">
+            <a:avLst/>
+          </a:prstGeom>
+          <a:noFill/>
+          <a:ln/>
+        </p:spPr>
+        <p:txBody>
+          <a:bodyPr wrap="square" rtlCol="0" anchor="t"/>
+          <a:lstStyle/>
+          <a:p>
+            <a:pPr algn="l" indent="0" marL="0">
+              <a:buNone/>
+            </a:pPr>
+            <a:r>
+              <a:rPr lang="en-US" sz="1800" dirty="0">
+                <a:solidFill>
+                  <a:srgbClr val="17406D"/>
+                </a:solidFill>
+                <a:latin typeface="Arial" pitchFamily="34" charset="0"/>
+                <a:ea typeface="Arial" pitchFamily="34" charset="-122"/>
+                <a:cs typeface="Arial" pitchFamily="34" charset="-120"/>
+              </a:rPr>
+              <a:t>传统病理诊断效率低</a:t>
+            </a:r>
+            <a:endParaRPr lang="en-US" sz="1800" dirty="0"/>
+          </a:p>
+          <a:p>
+            <a:pPr algn="l" indent="0" marL="0">
+              <a:buNone/>
+            </a:pPr>
+            <a:r>
+              <a:rPr lang="en-US" sz="1800" dirty="0">
+                <a:solidFill>
+                  <a:srgbClr val="17406D"/>
+                </a:solidFill>
+                <a:latin typeface="Arial" pitchFamily="34" charset="0"/>
+                <a:ea typeface="Arial" pitchFamily="34" charset="-122"/>
+                <a:cs typeface="Arial" pitchFamily="34" charset="-120"/>
+              </a:rPr>
+              <a:t>诊断准确性依赖医生经验</a:t>
+            </a:r>
+            <a:endParaRPr lang="en-US" sz="1800" dirty="0"/>
+          </a:p>
+          <a:p>
+            <a:pPr algn="l" indent="0" marL="0">
+              <a:buNone/>
+            </a:pPr>
+            <a:r>
+              <a:rPr lang="en-US" sz="1800" dirty="0">
+                <a:solidFill>
+                  <a:srgbClr val="17406D"/>
+                </a:solidFill>
+                <a:latin typeface="Arial" pitchFamily="34" charset="0"/>
+                <a:ea typeface="Arial" pitchFamily="34" charset="-122"/>
+                <a:cs typeface="Arial" pitchFamily="34" charset="-120"/>
+              </a:rPr>
+              <a:t>远程会诊能力不足</a:t>
+            </a:r>
+            <a:endParaRPr lang="en-US" sz="1800" dirty="0"/>
+          </a:p>
+        </p:txBody>
+      </p:sp>
+    </p:spTree>
+  </p:cSld>
+  <p:clrMapOvr>
+    <a:masterClrMapping/>
+  </p:clrMapOvr>
+</p:sld>
+</file>
+
+<file path=ppt/slides/slide4.xml><?xml version="1.0" encoding="utf-8"?>
+<p:sld xmlns:a="http://schemas.openxmlformats.org/drawingml/2006/main" xmlns:r="http://schemas.openxmlformats.org/officeDocument/2006/relationships" xmlns:p="http://schemas.openxmlformats.org/presentationml/2006/main">
+  <p:cSld name="Slide 4">
+    <p:bg>
+      <p:bgPr>
+        <a:blipFill dpi="0" rotWithShape="1">
+          <a:blip r:embed="rId1">
+            <a:lum/>
+          </a:blip>
+          <a:srcRect/>
+          <a:stretch>
+            <a:fillRect/>
+          </a:stretch>
+        </a:blipFill>
+        <a:effectLst/>
+      </p:bgPr>
+    </p:bg>
+    <p:spTree>
+      <p:nvGrpSpPr>
+        <p:cNvPr id="1" name=""/>
+        <p:cNvGrpSpPr/>
+        <p:nvPr/>
+      </p:nvGrpSpPr>
+      <p:grpSpPr>
+        <a:xfrm>
+          <a:off x="0" y="0"/>
+          <a:ext cx="0" cy="0"/>
+          <a:chOff x="0" y="0"/>
+          <a:chExt cx="0" cy="0"/>
+        </a:xfrm>
+      </p:grpSpPr>
+      <p:sp>
+        <p:nvSpPr>
+          <p:cNvPr id="2" name="Text 0"/>
+          <p:cNvSpPr/>
+          <p:nvPr/>
+        </p:nvSpPr>
+        <p:spPr>
+          <a:xfrm>
+            <a:off x="457200" y="457200"/>
+            <a:ext cx="8229600" cy="914400"/>
+          </a:xfrm>
+          <a:prstGeom prst="rect">
+            <a:avLst/>
+          </a:prstGeom>
+          <a:noFill/>
+          <a:ln/>
+        </p:spPr>
+        <p:txBody>
+          <a:bodyPr wrap="square" rtlCol="0" anchor="ctr"/>
+          <a:lstStyle/>
+          <a:p>
+            <a:pPr algn="l" indent="0" marL="0">
+              <a:buNone/>
+            </a:pPr>
+            <a:r>
+              <a:rPr lang="en-US" sz="4400" b="1" dirty="0">
+                <a:solidFill>
+                  <a:srgbClr val="17406D"/>
+                </a:solidFill>
+                <a:latin typeface="Arial" pitchFamily="34" charset="0"/>
+                <a:ea typeface="Arial" pitchFamily="34" charset="-122"/>
+                <a:cs typeface="Arial" pitchFamily="34" charset="-120"/>
+              </a:rPr>
+              <a:t>建设目标</a:t>
+            </a:r>
+            <a:endParaRPr lang="en-US" sz="4400" dirty="0"/>
+          </a:p>
+        </p:txBody>
+      </p:sp>
+      <p:sp>
+        <p:nvSpPr>
+          <p:cNvPr id="3" name="Text 1"/>
+          <p:cNvSpPr/>
+          <p:nvPr/>
+        </p:nvSpPr>
+        <p:spPr>
+          <a:xfrm>
+            <a:off x="457200" y="1645920"/>
+            <a:ext cx="8229600" cy="731520"/>
+          </a:xfrm>
+          <a:prstGeom prst="rect">
+            <a:avLst/>
+          </a:prstGeom>
+          <a:noFill/>
+          <a:ln/>
+        </p:spPr>
+        <p:txBody>
+          <a:bodyPr wrap="square" rtlCol="0" anchor="ctr"/>
+          <a:lstStyle/>
+          <a:p>
+            <a:pPr algn="l" indent="0" marL="0">
+              <a:buNone/>
+            </a:pPr>
+            <a:r>
+              <a:rPr lang="en-US" sz="2400" dirty="0">
+                <a:solidFill>
+                  <a:srgbClr val="009DD9"/>
+                </a:solidFill>
+                <a:latin typeface="Arial" pitchFamily="34" charset="0"/>
+                <a:ea typeface="Arial" pitchFamily="34" charset="-122"/>
+                <a:cs typeface="Arial" pitchFamily="34" charset="-120"/>
+              </a:rPr>
+              <a:t>打造数智化病理科</a:t>
+            </a:r>
+            <a:endParaRPr lang="en-US" sz="2400" dirty="0"/>
+          </a:p>
+        </p:txBody>
+      </p:sp>
+      <p:sp>
+        <p:nvSpPr>
+          <p:cNvPr id="4" name="Text 2"/>
+          <p:cNvSpPr/>
+          <p:nvPr/>
+        </p:nvSpPr>
+        <p:spPr>
+          <a:xfrm>
+            <a:off x="457200" y="2560320"/>
+            <a:ext cx="8229600" cy="2743200"/>
+          </a:xfrm>
+          <a:prstGeom prst="rect">
+            <a:avLst/>
+          </a:prstGeom>
+          <a:noFill/>
+          <a:ln/>
+        </p:spPr>
+        <p:txBody>
+          <a:bodyPr wrap="square" rtlCol="0" anchor="t"/>
+          <a:lstStyle/>
+          <a:p>
+            <a:pPr algn="l" indent="0" marL="0">
+              <a:buNone/>
+            </a:pPr>
+            <a:r>
+              <a:rPr lang="en-US" sz="1800" dirty="0">
+                <a:solidFill>
+                  <a:srgbClr val="17406D"/>
+                </a:solidFill>
+                <a:latin typeface="Arial" pitchFamily="34" charset="0"/>
+                <a:ea typeface="Arial" pitchFamily="34" charset="-122"/>
+                <a:cs typeface="Arial" pitchFamily="34" charset="-120"/>
+              </a:rPr>
+              <a:t>全流程数字化</a:t>
+            </a:r>
+            <a:endParaRPr lang="en-US" sz="1800" dirty="0"/>
+          </a:p>
+          <a:p>
+            <a:pPr algn="l" indent="0" marL="0">
+              <a:buNone/>
+            </a:pPr>
+            <a:r>
+              <a:rPr lang="en-US" sz="1800" dirty="0">
+                <a:solidFill>
+                  <a:srgbClr val="17406D"/>
+                </a:solidFill>
+                <a:latin typeface="Arial" pitchFamily="34" charset="0"/>
+                <a:ea typeface="Arial" pitchFamily="34" charset="-122"/>
+                <a:cs typeface="Arial" pitchFamily="34" charset="-120"/>
+              </a:rPr>
+              <a:t>AI 辅助诊断</a:t>
+            </a:r>
+            <a:endParaRPr lang="en-US" sz="1800" dirty="0"/>
+          </a:p>
+          <a:p>
+            <a:pPr algn="l" indent="0" marL="0">
+              <a:buNone/>
+            </a:pPr>
+            <a:r>
+              <a:rPr lang="en-US" sz="1800" dirty="0">
+                <a:solidFill>
+                  <a:srgbClr val="17406D"/>
+                </a:solidFill>
+                <a:latin typeface="Arial" pitchFamily="34" charset="0"/>
+                <a:ea typeface="Arial" pitchFamily="34" charset="-122"/>
+                <a:cs typeface="Arial" pitchFamily="34" charset="-120"/>
+              </a:rPr>
+              <a:t>远程会诊平台</a:t>
+            </a:r>
+            <a:endParaRPr lang="en-US" sz="1800" dirty="0"/>
+          </a:p>
+          <a:p>
+            <a:pPr algn="l" indent="0" marL="0">
+              <a:buNone/>
+            </a:pPr>
+            <a:r>
+              <a:rPr lang="en-US" sz="1800" dirty="0">
+                <a:solidFill>
+                  <a:srgbClr val="17406D"/>
+                </a:solidFill>
+                <a:latin typeface="Arial" pitchFamily="34" charset="0"/>
+                <a:ea typeface="Arial" pitchFamily="34" charset="-122"/>
+                <a:cs typeface="Arial" pitchFamily="34" charset="-120"/>
+              </a:rPr>
+              <a:t>科研数据资产化</a:t>
+            </a:r>
+            <a:endParaRPr lang="en-US" sz="1800" dirty="0"/>
+          </a:p>
+        </p:txBody>
+      </p:sp>
+    </p:spTree>
+  </p:cSld>
+  <p:clrMapOvr>
+    <a:masterClrMapping/>
+  </p:clrMapOvr>
+</p:sld>
+</file>
+
+<file path=ppt/slides/slide5.xml><?xml version="1.0" encoding="utf-8"?>
+<p:sld xmlns:a="http://schemas.openxmlformats.org/drawingml/2006/main" xmlns:r="http://schemas.openxmlformats.org/officeDocument/2006/relationships" xmlns:p="http://schemas.openxmlformats.org/presentationml/2006/main">
+  <p:cSld name="Slide 5">
+    <p:bg>
+      <p:bgPr>
+        <a:blipFill dpi="0" rotWithShape="1">
+          <a:blip r:embed="rId1">
+            <a:lum/>
+          </a:blip>
+          <a:srcRect/>
+          <a:stretch>
+            <a:fillRect/>
+          </a:stretch>
+        </a:blipFill>
+        <a:effectLst/>
+      </p:bgPr>
+    </p:bg>
+    <p:spTree>
+      <p:nvGrpSpPr>
+        <p:cNvPr id="1" name=""/>
+        <p:cNvGrpSpPr/>
+        <p:nvPr/>
+      </p:nvGrpSpPr>
+      <p:grpSpPr>
+        <a:xfrm>
+          <a:off x="0" y="0"/>
+          <a:ext cx="0" cy="0"/>
+          <a:chOff x="0" y="0"/>
+          <a:chExt cx="0" cy="0"/>
+        </a:xfrm>
+      </p:grpSpPr>
+      <p:sp>
+        <p:nvSpPr>
+          <p:cNvPr id="2" name="Text 0"/>
+          <p:cNvSpPr/>
+          <p:nvPr/>
+        </p:nvSpPr>
+        <p:spPr>
+          <a:xfrm>
+            <a:off x="457200" y="457200"/>
+            <a:ext cx="8229600" cy="914400"/>
+          </a:xfrm>
+          <a:prstGeom prst="rect">
+            <a:avLst/>
+          </a:prstGeom>
+          <a:noFill/>
+          <a:ln/>
+        </p:spPr>
+        <p:txBody>
+          <a:bodyPr wrap="square" rtlCol="0" anchor="ctr"/>
+          <a:lstStyle/>
+          <a:p>
+            <a:pPr algn="l" indent="0" marL="0">
+              <a:buNone/>
+            </a:pPr>
+            <a:r>
+              <a:rPr lang="en-US" sz="4400" b="1" dirty="0">
+                <a:solidFill>
+                  <a:srgbClr val="17406D"/>
+                </a:solidFill>
+                <a:latin typeface="Arial" pitchFamily="34" charset="0"/>
+                <a:ea typeface="Arial" pitchFamily="34" charset="-122"/>
+                <a:cs typeface="Arial" pitchFamily="34" charset="-120"/>
+              </a:rPr>
+              <a:t>技术方案</a:t>
+            </a:r>
+            <a:endParaRPr lang="en-US" sz="4400" dirty="0"/>
+          </a:p>
+        </p:txBody>
+      </p:sp>
+      <p:sp>
+        <p:nvSpPr>
+          <p:cNvPr id="3" name="Text 1"/>
+          <p:cNvSpPr/>
+          <p:nvPr/>
+        </p:nvSpPr>
+        <p:spPr>
+          <a:xfrm>
+            <a:off x="457200" y="1645920"/>
+            <a:ext cx="8229600" cy="731520"/>
+          </a:xfrm>
+          <a:prstGeom prst="rect">
+            <a:avLst/>
+          </a:prstGeom>
+          <a:noFill/>
+          <a:ln/>
+        </p:spPr>
+        <p:txBody>
+          <a:bodyPr wrap="square" rtlCol="0" anchor="ctr"/>
+          <a:lstStyle/>
+          <a:p>
+            <a:pPr algn="l" indent="0" marL="0">
+              <a:buNone/>
+            </a:pPr>
+            <a:r>
+              <a:rPr lang="en-US" sz="2400" dirty="0">
+                <a:solidFill>
+                  <a:srgbClr val="009DD9"/>
+                </a:solidFill>
+                <a:latin typeface="Arial" pitchFamily="34" charset="0"/>
+                <a:ea typeface="Arial" pitchFamily="34" charset="-122"/>
+                <a:cs typeface="Arial" pitchFamily="34" charset="-120"/>
+              </a:rPr>
+              <a:t>四大核心技术模块</a:t>
+            </a:r>
+            <a:endParaRPr lang="en-US" sz="2400" dirty="0"/>
+          </a:p>
+        </p:txBody>
+      </p:sp>
+      <p:sp>
+        <p:nvSpPr>
+          <p:cNvPr id="4" name="Text 2"/>
+          <p:cNvSpPr/>
+          <p:nvPr/>
+        </p:nvSpPr>
+        <p:spPr>
+          <a:xfrm>
+            <a:off x="457200" y="2560320"/>
+            <a:ext cx="8229600" cy="2743200"/>
+          </a:xfrm>
+          <a:prstGeom prst="rect">
+            <a:avLst/>
+          </a:prstGeom>
+          <a:noFill/>
+          <a:ln/>
+        </p:spPr>
+        <p:txBody>
+          <a:bodyPr wrap="square" rtlCol="0" anchor="t"/>
+          <a:lstStyle/>
+          <a:p>
+            <a:pPr algn="l" indent="0" marL="0">
+              <a:buNone/>
+            </a:pPr>
+            <a:r>
+              <a:rPr lang="en-US" sz="1800" dirty="0">
+                <a:solidFill>
+                  <a:srgbClr val="17406D"/>
+                </a:solidFill>
+                <a:latin typeface="Arial" pitchFamily="34" charset="0"/>
+                <a:ea typeface="Arial" pitchFamily="34" charset="-122"/>
+                <a:cs typeface="Arial" pitchFamily="34" charset="-120"/>
+              </a:rPr>
+              <a:t>数字病理扫描仪</a:t>
+            </a:r>
+            <a:endParaRPr lang="en-US" sz="1800" dirty="0"/>
+          </a:p>
+          <a:p>
+            <a:pPr algn="l" indent="0" marL="0">
+              <a:buNone/>
+            </a:pPr>
+            <a:r>
+              <a:rPr lang="en-US" sz="1800" dirty="0">
+                <a:solidFill>
+                  <a:srgbClr val="17406D"/>
+                </a:solidFill>
+                <a:latin typeface="Arial" pitchFamily="34" charset="0"/>
+                <a:ea typeface="Arial" pitchFamily="34" charset="-122"/>
+                <a:cs typeface="Arial" pitchFamily="34" charset="-120"/>
+              </a:rPr>
+              <a:t>AI 辅助诊断系统</a:t>
+            </a:r>
+            <a:endParaRPr lang="en-US" sz="1800" dirty="0"/>
+          </a:p>
+          <a:p>
+            <a:pPr algn="l" indent="0" marL="0">
+              <a:buNone/>
+            </a:pPr>
+            <a:r>
+              <a:rPr lang="en-US" sz="1800" dirty="0">
+                <a:solidFill>
+                  <a:srgbClr val="17406D"/>
+                </a:solidFill>
+                <a:latin typeface="Arial" pitchFamily="34" charset="0"/>
+                <a:ea typeface="Arial" pitchFamily="34" charset="-122"/>
+                <a:cs typeface="Arial" pitchFamily="34" charset="-120"/>
+              </a:rPr>
+              <a:t>远程会诊平台</a:t>
+            </a:r>
+            <a:endParaRPr lang="en-US" sz="1800" dirty="0"/>
+          </a:p>
+          <a:p>
+            <a:pPr algn="l" indent="0" marL="0">
+              <a:buNone/>
+            </a:pPr>
+            <a:r>
+              <a:rPr lang="en-US" sz="1800" dirty="0">
+                <a:solidFill>
+                  <a:srgbClr val="17406D"/>
+                </a:solidFill>
+                <a:latin typeface="Arial" pitchFamily="34" charset="0"/>
+                <a:ea typeface="Arial" pitchFamily="34" charset="-122"/>
+                <a:cs typeface="Arial" pitchFamily="34" charset="-120"/>
+              </a:rPr>
+              <a:t>数据安全管理</a:t>
+            </a:r>
+            <a:endParaRPr lang="en-US" sz="1800" dirty="0"/>
+          </a:p>
+        </p:txBody>
+      </p:sp>
+    </p:spTree>
+  </p:cSld>
+  <p:clrMapOvr>
+    <a:masterClrMapping/>
+  </p:clrMapOvr>
+</p:sld>
+</file>
+
+<file path=ppt/slides/slide6.xml><?xml version="1.0" encoding="utf-8"?>
+<p:sld xmlns:a="http://schemas.openxmlformats.org/drawingml/2006/main" xmlns:r="http://schemas.openxmlformats.org/officeDocument/2006/relationships" xmlns:p="http://schemas.openxmlformats.org/presentationml/2006/main">
+  <p:cSld name="Slide 6">
+    <p:bg>
+      <p:bgPr>
+        <a:blipFill dpi="0" rotWithShape="1">
+          <a:blip r:embed="rId1">
+            <a:lum/>
+          </a:blip>
+          <a:srcRect/>
+          <a:stretch>
+            <a:fillRect/>
+          </a:stretch>
+        </a:blipFill>
+        <a:effectLst/>
+      </p:bgPr>
+    </p:bg>
+    <p:spTree>
+      <p:nvGrpSpPr>
+        <p:cNvPr id="1" name=""/>
+        <p:cNvGrpSpPr/>
+        <p:nvPr/>
+      </p:nvGrpSpPr>
+      <p:grpSpPr>
+        <a:xfrm>
+          <a:off x="0" y="0"/>
+          <a:ext cx="0" cy="0"/>
+          <a:chOff x="0" y="0"/>
+          <a:chExt cx="0" cy="0"/>
+        </a:xfrm>
+      </p:grpSpPr>
+      <p:sp>
+        <p:nvSpPr>
+          <p:cNvPr id="2" name="Text 0"/>
+          <p:cNvSpPr/>
+          <p:nvPr/>
+        </p:nvSpPr>
+        <p:spPr>
+          <a:xfrm>
+            <a:off x="457200" y="457200"/>
+            <a:ext cx="8229600" cy="914400"/>
+          </a:xfrm>
+          <a:prstGeom prst="rect">
+            <a:avLst/>
+          </a:prstGeom>
+          <a:noFill/>
+          <a:ln/>
+        </p:spPr>
+        <p:txBody>
+          <a:bodyPr wrap="square" rtlCol="0" anchor="ctr"/>
+          <a:lstStyle/>
+          <a:p>
+            <a:pPr algn="l" indent="0" marL="0">
+              <a:buNone/>
+            </a:pPr>
+            <a:r>
+              <a:rPr lang="en-US" sz="4400" b="1" dirty="0">
+                <a:solidFill>
+                  <a:srgbClr val="17406D"/>
+                </a:solidFill>
+                <a:latin typeface="Arial" pitchFamily="34" charset="0"/>
+                <a:ea typeface="Arial" pitchFamily="34" charset="-122"/>
+                <a:cs typeface="Arial" pitchFamily="34" charset="-120"/>
+              </a:rPr>
+              <a:t>数字病理扫描仪</a:t>
+            </a:r>
+            <a:endParaRPr lang="en-US" sz="4400" dirty="0"/>
+          </a:p>
+        </p:txBody>
+      </p:sp>
+      <p:sp>
+        <p:nvSpPr>
+          <p:cNvPr id="3" name="Text 1"/>
+          <p:cNvSpPr/>
+          <p:nvPr/>
+        </p:nvSpPr>
+        <p:spPr>
+          <a:xfrm>
+            <a:off x="457200" y="1645920"/>
+            <a:ext cx="8229600" cy="731520"/>
+          </a:xfrm>
+          <a:prstGeom prst="rect">
+            <a:avLst/>
+          </a:prstGeom>
+          <a:noFill/>
+          <a:ln/>
+        </p:spPr>
+        <p:txBody>
+          <a:bodyPr wrap="square" rtlCol="0" anchor="ctr"/>
+          <a:lstStyle/>
+          <a:p>
+            <a:pPr algn="l" indent="0" marL="0">
+              <a:buNone/>
+            </a:pPr>
+            <a:r>
+              <a:rPr lang="en-US" sz="2400" dirty="0">
+                <a:solidFill>
+                  <a:srgbClr val="009DD9"/>
+                </a:solidFill>
+                <a:latin typeface="Arial" pitchFamily="34" charset="0"/>
+                <a:ea typeface="Arial" pitchFamily="34" charset="-122"/>
+                <a:cs typeface="Arial" pitchFamily="34" charset="-120"/>
+              </a:rPr>
+              <a:t>高分辨率全切片成像</a:t>
+            </a:r>
+            <a:endParaRPr lang="en-US" sz="2400" dirty="0"/>
+          </a:p>
+        </p:txBody>
+      </p:sp>
+      <p:sp>
+        <p:nvSpPr>
+          <p:cNvPr id="4" name="Text 2"/>
+          <p:cNvSpPr/>
+          <p:nvPr/>
+        </p:nvSpPr>
+        <p:spPr>
+          <a:xfrm>
+            <a:off x="457200" y="2560320"/>
+            <a:ext cx="8229600" cy="2743200"/>
+          </a:xfrm>
+          <a:prstGeom prst="rect">
+            <a:avLst/>
+          </a:prstGeom>
+          <a:noFill/>
+          <a:ln/>
+        </p:spPr>
+        <p:txBody>
+          <a:bodyPr wrap="square" rtlCol="0" anchor="t"/>
+          <a:lstStyle/>
+          <a:p>
+            <a:pPr algn="l" indent="0" marL="0">
+              <a:buNone/>
+            </a:pPr>
+            <a:r>
+              <a:rPr lang="en-US" sz="1800" dirty="0">
+                <a:solidFill>
+                  <a:srgbClr val="17406D"/>
+                </a:solidFill>
+                <a:latin typeface="Arial" pitchFamily="34" charset="0"/>
+                <a:ea typeface="Arial" pitchFamily="34" charset="-122"/>
+                <a:cs typeface="Arial" pitchFamily="34" charset="-120"/>
+              </a:rPr>
+              <a:t>20x-40x 物镜</a:t>
+            </a:r>
+            <a:endParaRPr lang="en-US" sz="1800" dirty="0"/>
+          </a:p>
+          <a:p>
+            <a:pPr algn="l" indent="0" marL="0">
+              <a:buNone/>
+            </a:pPr>
+            <a:r>
+              <a:rPr lang="en-US" sz="1800" dirty="0">
+                <a:solidFill>
+                  <a:srgbClr val="17406D"/>
+                </a:solidFill>
+                <a:latin typeface="Arial" pitchFamily="34" charset="0"/>
+                <a:ea typeface="Arial" pitchFamily="34" charset="-122"/>
+                <a:cs typeface="Arial" pitchFamily="34" charset="-120"/>
+              </a:rPr>
+              <a:t>全自动扫描</a:t>
+            </a:r>
+            <a:endParaRPr lang="en-US" sz="1800" dirty="0"/>
+          </a:p>
+          <a:p>
+            <a:pPr algn="l" indent="0" marL="0">
+              <a:buNone/>
+            </a:pPr>
+            <a:r>
+              <a:rPr lang="en-US" sz="1800" dirty="0">
+                <a:solidFill>
+                  <a:srgbClr val="17406D"/>
+                </a:solidFill>
+                <a:latin typeface="Arial" pitchFamily="34" charset="0"/>
+                <a:ea typeface="Arial" pitchFamily="34" charset="-122"/>
+                <a:cs typeface="Arial" pitchFamily="34" charset="-120"/>
+              </a:rPr>
+              <a:t>30 秒/切片</a:t>
+            </a:r>
+            <a:endParaRPr lang="en-US" sz="1800" dirty="0"/>
+          </a:p>
+          <a:p>
+            <a:pPr algn="l" indent="0" marL="0">
+              <a:buNone/>
+            </a:pPr>
+            <a:r>
+              <a:rPr lang="en-US" sz="1800" dirty="0">
+                <a:solidFill>
+                  <a:srgbClr val="17406D"/>
+                </a:solidFill>
+                <a:latin typeface="Arial" pitchFamily="34" charset="0"/>
+                <a:ea typeface="Arial" pitchFamily="34" charset="-122"/>
+                <a:cs typeface="Arial" pitchFamily="34" charset="-120"/>
+              </a:rPr>
+              <a:t>支持多种染色</a:t>
+            </a:r>
+            <a:endParaRPr lang="en-US" sz="1800" dirty="0"/>
+          </a:p>
+        </p:txBody>
+      </p:sp>
+    </p:spTree>
+  </p:cSld>
+  <p:clrMapOvr>
+    <a:masterClrMapping/>
+  </p:clrMapOvr>
+</p:sld>
+</file>
+
+<file path=ppt/slides/slide7.xml><?xml version="1.0" encoding="utf-8"?>
+<p:sld xmlns:a="http://schemas.openxmlformats.org/drawingml/2006/main" xmlns:r="http://schemas.openxmlformats.org/officeDocument/2006/relationships" xmlns:p="http://schemas.openxmlformats.org/presentationml/2006/main">
+  <p:cSld name="Slide 7">
+    <p:bg>
+      <p:bgPr>
+        <a:blipFill dpi="0" rotWithShape="1">
+          <a:blip r:embed="rId1">
+            <a:lum/>
+          </a:blip>
+          <a:srcRect/>
+          <a:stretch>
+            <a:fillRect/>
+          </a:stretch>
+        </a:blipFill>
+        <a:effectLst/>
+      </p:bgPr>
+    </p:bg>
+    <p:spTree>
+      <p:nvGrpSpPr>
+        <p:cNvPr id="1" name=""/>
+        <p:cNvGrpSpPr/>
+        <p:nvPr/>
+      </p:nvGrpSpPr>
+      <p:grpSpPr>
+        <a:xfrm>
+          <a:off x="0" y="0"/>
+          <a:ext cx="0" cy="0"/>
+          <a:chOff x="0" y="0"/>
+          <a:chExt cx="0" cy="0"/>
+        </a:xfrm>
+      </p:grpSpPr>
+      <p:sp>
+        <p:nvSpPr>
+          <p:cNvPr id="2" name="Text 0"/>
+          <p:cNvSpPr/>
+          <p:nvPr/>
+        </p:nvSpPr>
+        <p:spPr>
+          <a:xfrm>
+            <a:off x="457200" y="457200"/>
+            <a:ext cx="8229600" cy="914400"/>
+          </a:xfrm>
+          <a:prstGeom prst="rect">
+            <a:avLst/>
+          </a:prstGeom>
+          <a:noFill/>
+          <a:ln/>
+        </p:spPr>
+        <p:txBody>
+          <a:bodyPr wrap="square" rtlCol="0" anchor="ctr"/>
+          <a:lstStyle/>
+          <a:p>
+            <a:pPr algn="l" indent="0" marL="0">
+              <a:buNone/>
+            </a:pPr>
+            <a:r>
+              <a:rPr lang="en-US" sz="4400" b="1" dirty="0">
+                <a:solidFill>
+                  <a:srgbClr val="17406D"/>
+                </a:solidFill>
+                <a:latin typeface="Arial" pitchFamily="34" charset="0"/>
+                <a:ea typeface="Arial" pitchFamily="34" charset="-122"/>
+                <a:cs typeface="Arial" pitchFamily="34" charset="-120"/>
+              </a:rPr>
+              <a:t>AI 辅助诊断系统</a:t>
+            </a:r>
+            <a:endParaRPr lang="en-US" sz="4400" dirty="0"/>
+          </a:p>
+        </p:txBody>
+      </p:sp>
+      <p:sp>
+        <p:nvSpPr>
+          <p:cNvPr id="3" name="Text 1"/>
+          <p:cNvSpPr/>
+          <p:nvPr/>
+        </p:nvSpPr>
+        <p:spPr>
+          <a:xfrm>
+            <a:off x="457200" y="1645920"/>
+            <a:ext cx="8229600" cy="731520"/>
+          </a:xfrm>
+          <a:prstGeom prst="rect">
+            <a:avLst/>
+          </a:prstGeom>
+          <a:noFill/>
+          <a:ln/>
+        </p:spPr>
+        <p:txBody>
+          <a:bodyPr wrap="square" rtlCol="0" anchor="ctr"/>
+          <a:lstStyle/>
+          <a:p>
+            <a:pPr algn="l" indent="0" marL="0">
+              <a:buNone/>
+            </a:pPr>
+            <a:r>
+              <a:rPr lang="en-US" sz="2400" dirty="0">
+                <a:solidFill>
+                  <a:srgbClr val="009DD9"/>
+                </a:solidFill>
+                <a:latin typeface="Arial" pitchFamily="34" charset="0"/>
+                <a:ea typeface="Arial" pitchFamily="34" charset="-122"/>
+                <a:cs typeface="Arial" pitchFamily="34" charset="-120"/>
+              </a:rPr>
+              <a:t>深度学习辅助诊断</a:t>
+            </a:r>
+            <a:endParaRPr lang="en-US" sz="2400" dirty="0"/>
+          </a:p>
+        </p:txBody>
+      </p:sp>
+      <p:sp>
+        <p:nvSpPr>
+          <p:cNvPr id="4" name="Text 2"/>
+          <p:cNvSpPr/>
+          <p:nvPr/>
+        </p:nvSpPr>
+        <p:spPr>
+          <a:xfrm>
+            <a:off x="457200" y="2560320"/>
+            <a:ext cx="8229600" cy="2743200"/>
+          </a:xfrm>
+          <a:prstGeom prst="rect">
+            <a:avLst/>
+          </a:prstGeom>
+          <a:noFill/>
+          <a:ln/>
+        </p:spPr>
+        <p:txBody>
+          <a:bodyPr wrap="square" rtlCol="0" anchor="t"/>
+          <a:lstStyle/>
+          <a:p>
+            <a:pPr algn="l" indent="0" marL="0">
+              <a:buNone/>
+            </a:pPr>
+            <a:r>
+              <a:rPr lang="en-US" sz="1800" dirty="0">
+                <a:solidFill>
+                  <a:srgbClr val="17406D"/>
+                </a:solidFill>
+                <a:latin typeface="Arial" pitchFamily="34" charset="0"/>
+                <a:ea typeface="Arial" pitchFamily="34" charset="-122"/>
+                <a:cs typeface="Arial" pitchFamily="34" charset="-120"/>
+              </a:rPr>
+              <a:t>宫颈癌筛查</a:t>
+            </a:r>
+            <a:endParaRPr lang="en-US" sz="1800" dirty="0"/>
+          </a:p>
+          <a:p>
+            <a:pPr algn="l" indent="0" marL="0">
+              <a:buNone/>
+            </a:pPr>
+            <a:r>
+              <a:rPr lang="en-US" sz="1800" dirty="0">
+                <a:solidFill>
+                  <a:srgbClr val="17406D"/>
+                </a:solidFill>
+                <a:latin typeface="Arial" pitchFamily="34" charset="0"/>
+                <a:ea typeface="Arial" pitchFamily="34" charset="-122"/>
+                <a:cs typeface="Arial" pitchFamily="34" charset="-120"/>
+              </a:rPr>
+              <a:t>乳腺癌诊断</a:t>
+            </a:r>
+            <a:endParaRPr lang="en-US" sz="1800" dirty="0"/>
+          </a:p>
+          <a:p>
+            <a:pPr algn="l" indent="0" marL="0">
+              <a:buNone/>
+            </a:pPr>
+            <a:r>
+              <a:rPr lang="en-US" sz="1800" dirty="0">
+                <a:solidFill>
+                  <a:srgbClr val="17406D"/>
+                </a:solidFill>
+                <a:latin typeface="Arial" pitchFamily="34" charset="0"/>
+                <a:ea typeface="Arial" pitchFamily="34" charset="-122"/>
+                <a:cs typeface="Arial" pitchFamily="34" charset="-120"/>
+              </a:rPr>
+              <a:t>前列腺癌检测</a:t>
+            </a:r>
+            <a:endParaRPr lang="en-US" sz="1800" dirty="0"/>
+          </a:p>
+          <a:p>
+            <a:pPr algn="l" indent="0" marL="0">
+              <a:buNone/>
+            </a:pPr>
+            <a:r>
+              <a:rPr lang="en-US" sz="1800" dirty="0">
+                <a:solidFill>
+                  <a:srgbClr val="17406D"/>
+                </a:solidFill>
+                <a:latin typeface="Arial" pitchFamily="34" charset="0"/>
+                <a:ea typeface="Arial" pitchFamily="34" charset="-122"/>
+                <a:cs typeface="Arial" pitchFamily="34" charset="-120"/>
+              </a:rPr>
+              <a:t>细胞学分析</a:t>
+            </a:r>
+            <a:endParaRPr lang="en-US" sz="1800" dirty="0"/>
+          </a:p>
+        </p:txBody>
+      </p:sp>
+    </p:spTree>
+  </p:cSld>
+  <p:clrMapOvr>
+    <a:masterClrMapping/>
+  </p:clrMapOvr>
+</p:sld>
+</file>
+
+<file path=ppt/slides/slide8.xml><?xml version="1.0" encoding="utf-8"?>
+<p:sld xmlns:a="http://schemas.openxmlformats.org/drawingml/2006/main" xmlns:r="http://schemas.openxmlformats.org/officeDocument/2006/relationships" xmlns:p="http://schemas.openxmlformats.org/presentationml/2006/main">
+  <p:cSld name="Slide 8">
+    <p:bg>
+      <p:bgPr>
+        <a:blipFill dpi="0" rotWithShape="1">
+          <a:blip r:embed="rId1">
+            <a:lum/>
+          </a:blip>
+          <a:srcRect/>
+          <a:stretch>
+            <a:fillRect/>
+          </a:stretch>
+        </a:blipFill>
+        <a:effectLst/>
+      </p:bgPr>
+    </p:bg>
+    <p:spTree>
+      <p:nvGrpSpPr>
+        <p:cNvPr id="1" name=""/>
+        <p:cNvGrpSpPr/>
+        <p:nvPr/>
+      </p:nvGrpSpPr>
+      <p:grpSpPr>
+        <a:xfrm>
+          <a:off x="0" y="0"/>
+          <a:ext cx="0" cy="0"/>
+          <a:chOff x="0" y="0"/>
+          <a:chExt cx="0" cy="0"/>
+        </a:xfrm>
+      </p:grpSpPr>
+      <p:sp>
+        <p:nvSpPr>
+          <p:cNvPr id="2" name="Text 0"/>
+          <p:cNvSpPr/>
+          <p:nvPr/>
+        </p:nvSpPr>
+        <p:spPr>
+          <a:xfrm>
+            <a:off x="457200" y="457200"/>
+            <a:ext cx="8229600" cy="914400"/>
+          </a:xfrm>
+          <a:prstGeom prst="rect">
+            <a:avLst/>
+          </a:prstGeom>
+          <a:noFill/>
+          <a:ln/>
+        </p:spPr>
+        <p:txBody>
+          <a:bodyPr wrap="square" rtlCol="0" anchor="ctr"/>
+          <a:lstStyle/>
+          <a:p>
+            <a:pPr algn="l" indent="0" marL="0">
+              <a:buNone/>
+            </a:pPr>
+            <a:r>
+              <a:rPr lang="en-US" sz="4400" b="1" dirty="0">
+                <a:solidFill>
+                  <a:srgbClr val="17406D"/>
+                </a:solidFill>
+                <a:latin typeface="Arial" pitchFamily="34" charset="0"/>
+                <a:ea typeface="Arial" pitchFamily="34" charset="-122"/>
+                <a:cs typeface="Arial" pitchFamily="34" charset="-120"/>
+              </a:rPr>
+              <a:t>远程会诊平台</a:t>
+            </a:r>
+            <a:endParaRPr lang="en-US" sz="4400" dirty="0"/>
+          </a:p>
+        </p:txBody>
+      </p:sp>
+      <p:sp>
+        <p:nvSpPr>
+          <p:cNvPr id="3" name="Text 1"/>
+          <p:cNvSpPr/>
+          <p:nvPr/>
+        </p:nvSpPr>
+        <p:spPr>
+          <a:xfrm>
+            <a:off x="457200" y="1645920"/>
+            <a:ext cx="8229600" cy="731520"/>
+          </a:xfrm>
+          <a:prstGeom prst="rect">
+            <a:avLst/>
+          </a:prstGeom>
+          <a:noFill/>
+          <a:ln/>
+        </p:spPr>
+        <p:txBody>
+          <a:bodyPr wrap="square" rtlCol="0" anchor="ctr"/>
+          <a:lstStyle/>
+          <a:p>
+            <a:pPr algn="l" indent="0" marL="0">
+              <a:buNone/>
+            </a:pPr>
+            <a:r>
+              <a:rPr lang="en-US" sz="2400" dirty="0">
+                <a:solidFill>
+                  <a:srgbClr val="009DD9"/>
+                </a:solidFill>
+                <a:latin typeface="Arial" pitchFamily="34" charset="0"/>
+                <a:ea typeface="Arial" pitchFamily="34" charset="-122"/>
+                <a:cs typeface="Arial" pitchFamily="34" charset="-120"/>
+              </a:rPr>
+              <a:t>连接基层与上级医院</a:t>
+            </a:r>
+            <a:endParaRPr lang="en-US" sz="2400" dirty="0"/>
+          </a:p>
+        </p:txBody>
+      </p:sp>
+      <p:sp>
+        <p:nvSpPr>
+          <p:cNvPr id="4" name="Text 2"/>
+          <p:cNvSpPr/>
+          <p:nvPr/>
+        </p:nvSpPr>
+        <p:spPr>
+          <a:xfrm>
+            <a:off x="457200" y="2560320"/>
+            <a:ext cx="8229600" cy="2743200"/>
+          </a:xfrm>
+          <a:prstGeom prst="rect">
+            <a:avLst/>
+          </a:prstGeom>
+          <a:noFill/>
+          <a:ln/>
+        </p:spPr>
+        <p:txBody>
+          <a:bodyPr wrap="square" rtlCol="0" anchor="t"/>
+          <a:lstStyle/>
+          <a:p>
+            <a:pPr algn="l" indent="0" marL="0">
+              <a:buNone/>
+            </a:pPr>
+            <a:r>
+              <a:rPr lang="en-US" sz="1800" dirty="0">
+                <a:solidFill>
+                  <a:srgbClr val="17406D"/>
+                </a:solidFill>
+                <a:latin typeface="Arial" pitchFamily="34" charset="0"/>
+                <a:ea typeface="Arial" pitchFamily="34" charset="-122"/>
+                <a:cs typeface="Arial" pitchFamily="34" charset="-120"/>
+              </a:rPr>
+              <a:t>实时协作诊断</a:t>
+            </a:r>
+            <a:endParaRPr lang="en-US" sz="1800" dirty="0"/>
+          </a:p>
+          <a:p>
+            <a:pPr algn="l" indent="0" marL="0">
+              <a:buNone/>
+            </a:pPr>
+            <a:r>
+              <a:rPr lang="en-US" sz="1800" dirty="0">
+                <a:solidFill>
+                  <a:srgbClr val="17406D"/>
+                </a:solidFill>
+                <a:latin typeface="Arial" pitchFamily="34" charset="0"/>
+                <a:ea typeface="Arial" pitchFamily="34" charset="-122"/>
+                <a:cs typeface="Arial" pitchFamily="34" charset="-120"/>
+              </a:rPr>
+              <a:t>疑难病例讨论</a:t>
+            </a:r>
+            <a:endParaRPr lang="en-US" sz="1800" dirty="0"/>
+          </a:p>
+          <a:p>
+            <a:pPr algn="l" indent="0" marL="0">
+              <a:buNone/>
+            </a:pPr>
+            <a:r>
+              <a:rPr lang="en-US" sz="1800" dirty="0">
+                <a:solidFill>
+                  <a:srgbClr val="17406D"/>
+                </a:solidFill>
+                <a:latin typeface="Arial" pitchFamily="34" charset="0"/>
+                <a:ea typeface="Arial" pitchFamily="34" charset="-122"/>
+                <a:cs typeface="Arial" pitchFamily="34" charset="-120"/>
+              </a:rPr>
+              <a:t>继续教育学习</a:t>
+            </a:r>
+            <a:endParaRPr lang="en-US" sz="1800" dirty="0"/>
+          </a:p>
+          <a:p>
+            <a:pPr algn="l" indent="0" marL="0">
+              <a:buNone/>
+            </a:pPr>
+            <a:r>
+              <a:rPr lang="en-US" sz="1800" dirty="0">
+                <a:solidFill>
+                  <a:srgbClr val="17406D"/>
+                </a:solidFill>
+                <a:latin typeface="Arial" pitchFamily="34" charset="0"/>
+                <a:ea typeface="Arial" pitchFamily="34" charset="-122"/>
+                <a:cs typeface="Arial" pitchFamily="34" charset="-120"/>
+              </a:rPr>
+              <a:t>质控管理</a:t>
+            </a:r>
+            <a:endParaRPr lang="en-US" sz="1800" dirty="0"/>
+          </a:p>
+        </p:txBody>
+      </p:sp>
+    </p:spTree>
+  </p:cSld>
+  <p:clrMapOvr>
+    <a:masterClrMapping/>
+  </p:clrMapOvr>
+</p:sld>
+</file>
+
+<file path=ppt/slides/slide9.xml><?xml version="1.0" encoding="utf-8"?>
+<p:sld xmlns:a="http://schemas.openxmlformats.org/drawingml/2006/main" xmlns:r="http://schemas.openxmlformats.org/officeDocument/2006/relationships" xmlns:p="http://schemas.openxmlformats.org/presentationml/2006/main">
+  <p:cSld name="Slide 9">
+    <p:bg>
+      <p:bgPr>
+        <a:blipFill dpi="0" rotWithShape="1">
+          <a:blip r:embed="rId1">
+            <a:lum/>
+          </a:blip>
+          <a:srcRect/>
+          <a:stretch>
+            <a:fillRect/>
+          </a:stretch>
+        </a:blipFill>
+        <a:effectLst/>
+      </p:bgPr>
+    </p:bg>
+    <p:spTree>
+      <p:nvGrpSpPr>
+        <p:cNvPr id="1" name=""/>
+        <p:cNvGrpSpPr/>
+        <p:nvPr/>
+      </p:nvGrpSpPr>
+      <p:grpSpPr>
+        <a:xfrm>
+          <a:off x="0" y="0"/>
+          <a:ext cx="0" cy="0"/>
+          <a:chOff x="0" y="0"/>
+          <a:chExt cx="0" cy="0"/>
+        </a:xfrm>
+      </p:grpSpPr>
+      <p:sp>
+        <p:nvSpPr>
+          <p:cNvPr id="2" name="Text 0"/>
+          <p:cNvSpPr/>
+          <p:nvPr/>
+        </p:nvSpPr>
+        <p:spPr>
+          <a:xfrm>
+            <a:off x="457200" y="457200"/>
+            <a:ext cx="8229600" cy="914400"/>
+          </a:xfrm>
+          <a:prstGeom prst="rect">
+            <a:avLst/>
+          </a:prstGeom>
+          <a:noFill/>
+          <a:ln/>
+        </p:spPr>
+        <p:txBody>
+          <a:bodyPr wrap="square" rtlCol="0" anchor="ctr"/>
+          <a:lstStyle/>
+          <a:p>
+            <a:pPr algn="l" indent="0" marL="0">
+              <a:buNone/>
+            </a:pPr>
+            <a:r>
+              <a:rPr lang="en-US" sz="4400" b="1" dirty="0">
+                <a:solidFill>
+                  <a:srgbClr val="17406D"/>
+                </a:solidFill>
+                <a:latin typeface="Arial" pitchFamily="34" charset="0"/>
+                <a:ea typeface="Arial" pitchFamily="34" charset="-122"/>
+                <a:cs typeface="Arial" pitchFamily="34" charset="-120"/>
+              </a:rPr>
+              <a:t>预期效益</a:t>
+            </a:r>
+            <a:endParaRPr lang="en-US" sz="4400" dirty="0"/>
+          </a:p>
+        </p:txBody>
+      </p:sp>
+      <p:sp>
+        <p:nvSpPr>
+          <p:cNvPr id="3" name="Text 1"/>
+          <p:cNvSpPr/>
+          <p:nvPr/>
+        </p:nvSpPr>
+        <p:spPr>
+          <a:xfrm>
+            <a:off x="457200" y="1645920"/>
+            <a:ext cx="8229600" cy="731520"/>
+          </a:xfrm>
+          <a:prstGeom prst="rect">
+            <a:avLst/>
+          </a:prstGeom>
+          <a:noFill/>
+          <a:ln/>
+        </p:spPr>
+        <p:txBody>
+          <a:bodyPr wrap="square" rtlCol="0" anchor="ctr"/>
+          <a:lstStyle/>
+          <a:p>
+            <a:pPr algn="l" indent="0" marL="0">
+              <a:buNone/>
+            </a:pPr>
+            <a:r>
+              <a:rPr lang="en-US" sz="2400" dirty="0">
+                <a:solidFill>
+                  <a:srgbClr val="009DD9"/>
+                </a:solidFill>
+                <a:latin typeface="Arial" pitchFamily="34" charset="0"/>
+                <a:ea typeface="Arial" pitchFamily="34" charset="-122"/>
+                <a:cs typeface="Arial" pitchFamily="34" charset="-120"/>
+              </a:rPr>
+              <a:t>多维度价值提升</a:t>
+            </a:r>
+            <a:endParaRPr lang="en-US" sz="2400" dirty="0"/>
+          </a:p>
+        </p:txBody>
+      </p:sp>
+      <p:sp>
+        <p:nvSpPr>
+          <p:cNvPr id="4" name="Text 2"/>
+          <p:cNvSpPr/>
+          <p:nvPr/>
+        </p:nvSpPr>
+        <p:spPr>
+          <a:xfrm>
+            <a:off x="457200" y="2560320"/>
+            <a:ext cx="8229600" cy="2743200"/>
+          </a:xfrm>
+          <a:prstGeom prst="rect">
+            <a:avLst/>
+          </a:prstGeom>
+          <a:noFill/>
+          <a:ln/>
+        </p:spPr>
+        <p:txBody>
+          <a:bodyPr wrap="square" rtlCol="0" anchor="t"/>
+          <a:lstStyle/>
+          <a:p>
+            <a:pPr algn="l" indent="0" marL="0">
+              <a:buNone/>
+            </a:pPr>
+            <a:r>
+              <a:rPr lang="en-US" sz="1800" dirty="0">
+                <a:solidFill>
+                  <a:srgbClr val="17406D"/>
+                </a:solidFill>
+                <a:latin typeface="Arial" pitchFamily="34" charset="0"/>
+                <a:ea typeface="Arial" pitchFamily="34" charset="-122"/>
+                <a:cs typeface="Arial" pitchFamily="34" charset="-120"/>
+              </a:rPr>
+              <a:t>诊断效率提升 50%</a:t>
+            </a:r>
+            <a:endParaRPr lang="en-US" sz="1800" dirty="0"/>
+          </a:p>
+          <a:p>
+            <a:pPr algn="l" indent="0" marL="0">
+              <a:buNone/>
+            </a:pPr>
+            <a:r>
+              <a:rPr lang="en-US" sz="1800" dirty="0">
+                <a:solidFill>
+                  <a:srgbClr val="17406D"/>
+                </a:solidFill>
+                <a:latin typeface="Arial" pitchFamily="34" charset="0"/>
+                <a:ea typeface="Arial" pitchFamily="34" charset="-122"/>
+                <a:cs typeface="Arial" pitchFamily="34" charset="-120"/>
+              </a:rPr>
+              <a:t>诊断准确率提升 20%</a:t>
+            </a:r>
+            <a:endParaRPr lang="en-US" sz="1800" dirty="0"/>
+          </a:p>
+          <a:p>
+            <a:pPr algn="l" indent="0" marL="0">
+              <a:buNone/>
+            </a:pPr>
+            <a:r>
+              <a:rPr lang="en-US" sz="1800" dirty="0">
+                <a:solidFill>
+                  <a:srgbClr val="17406D"/>
+                </a:solidFill>
+                <a:latin typeface="Arial" pitchFamily="34" charset="0"/>
+                <a:ea typeface="Arial" pitchFamily="34" charset="-122"/>
+                <a:cs typeface="Arial" pitchFamily="34" charset="-120"/>
+              </a:rPr>
+              <a:t>远程会诊覆盖 10+ 医院</a:t>
+            </a:r>
+            <a:endParaRPr lang="en-US" sz="1800" dirty="0"/>
+          </a:p>
+          <a:p>
+            <a:pPr algn="l" indent="0" marL="0">
+              <a:buNone/>
+            </a:pPr>
+            <a:r>
+              <a:rPr lang="en-US" sz="1800" dirty="0">
+                <a:solidFill>
+                  <a:srgbClr val="17406D"/>
+                </a:solidFill>
+                <a:latin typeface="Arial" pitchFamily="34" charset="0"/>
+                <a:ea typeface="Arial" pitchFamily="34" charset="-122"/>
+                <a:cs typeface="Arial" pitchFamily="34" charset="-120"/>
+              </a:rPr>
+              <a:t>科研数据资产化</a:t>
+            </a:r>
+            <a:endParaRPr lang="en-US" sz="1800" dirty="0"/>
+          </a:p>
+        </p:txBody>
+      </p:sp>
+    </p:spTree>
+  </p:cSld>
+  <p:clrMapOvr>
+    <a:masterClrMapping/>
+  </p:clrMapOvr>
+</p:sld>
+</file>
+
 <file path=ppt/theme/theme1.xml><?xml version="1.0" encoding="utf-8"?>
 <a:theme xmlns:a="http://schemas.openxmlformats.org/drawingml/2006/main" name="Office Theme">
   <a:themeElements>

</xml_diff>